<commit_message>
Final adjustments & slide deck completion
</commit_message>
<xml_diff>
--- a/slide-deck.pptx
+++ b/slide-deck.pptx
@@ -7,11 +7,18 @@
   <p:sldIdLst>
     <p:sldId id="256" r:id="rId2"/>
     <p:sldId id="257" r:id="rId3"/>
-    <p:sldId id="258" r:id="rId4"/>
-    <p:sldId id="259" r:id="rId5"/>
-    <p:sldId id="261" r:id="rId6"/>
-    <p:sldId id="262" r:id="rId7"/>
-    <p:sldId id="263" r:id="rId8"/>
+    <p:sldId id="265" r:id="rId4"/>
+    <p:sldId id="258" r:id="rId5"/>
+    <p:sldId id="259" r:id="rId6"/>
+    <p:sldId id="261" r:id="rId7"/>
+    <p:sldId id="262" r:id="rId8"/>
+    <p:sldId id="263" r:id="rId9"/>
+    <p:sldId id="264" r:id="rId10"/>
+    <p:sldId id="266" r:id="rId11"/>
+    <p:sldId id="267" r:id="rId12"/>
+    <p:sldId id="269" r:id="rId13"/>
+    <p:sldId id="270" r:id="rId14"/>
+    <p:sldId id="272" r:id="rId15"/>
   </p:sldIdLst>
   <p:sldSz cx="12192000" cy="6858000"/>
   <p:notesSz cx="6858000" cy="9144000"/>
@@ -2337,10 +2344,10 @@
       </p:grpSpPr>
       <p:pic>
         <p:nvPicPr>
-          <p:cNvPr id="7" name="Picture 6">
+          <p:cNvPr id="4" name="Picture 3">
             <a:extLst>
               <a:ext uri="{FF2B5EF4-FFF2-40B4-BE49-F238E27FC236}">
-                <a16:creationId xmlns:a16="http://schemas.microsoft.com/office/drawing/2014/main" id="{3036A5E4-B82C-5AF3-482C-881B563F0A71}"/>
+                <a16:creationId xmlns:a16="http://schemas.microsoft.com/office/drawing/2014/main" id="{99FECBC2-EA38-2D6B-EBC9-A9AD5FA929FC}"/>
               </a:ext>
             </a:extLst>
           </p:cNvPr>
@@ -2350,17 +2357,15 @@
           <p:nvPr/>
         </p:nvPicPr>
         <p:blipFill>
-          <a:blip r:embed="rId2">
-            <a:alphaModFix amt="85000"/>
-          </a:blip>
+          <a:blip r:embed="rId2"/>
           <a:stretch>
             <a:fillRect/>
           </a:stretch>
         </p:blipFill>
         <p:spPr>
           <a:xfrm>
-            <a:off x="354192" y="934840"/>
-            <a:ext cx="11483616" cy="4988321"/>
+            <a:off x="118946" y="66907"/>
+            <a:ext cx="11954107" cy="6724185"/>
           </a:xfrm>
           <a:prstGeom prst="rect">
             <a:avLst/>
@@ -2428,7 +2433,7 @@
           <a:p>
             <a:r>
               <a:rPr lang="sk-SK" b="1" noProof="0" dirty="0"/>
-              <a:t>Maximilián Cenkner | II.D</a:t>
+              <a:t>Maximilián Cenkner</a:t>
             </a:r>
           </a:p>
         </p:txBody>
@@ -2437,6 +2442,1239 @@
     <p:extLst>
       <p:ext uri="{BB962C8B-B14F-4D97-AF65-F5344CB8AC3E}">
         <p14:creationId xmlns:p14="http://schemas.microsoft.com/office/powerpoint/2010/main" val="2537662987"/>
+      </p:ext>
+    </p:extLst>
+  </p:cSld>
+  <p:clrMapOvr>
+    <a:masterClrMapping/>
+  </p:clrMapOvr>
+</p:sld>
+</file>
+
+<file path=ppt/slides/slide10.xml><?xml version="1.0" encoding="utf-8"?>
+<p:sld xmlns:a="http://schemas.openxmlformats.org/drawingml/2006/main" xmlns:r="http://schemas.openxmlformats.org/officeDocument/2006/relationships" xmlns:p="http://schemas.openxmlformats.org/presentationml/2006/main">
+  <p:cSld>
+    <p:spTree>
+      <p:nvGrpSpPr>
+        <p:cNvPr id="1" name=""/>
+        <p:cNvGrpSpPr/>
+        <p:nvPr/>
+      </p:nvGrpSpPr>
+      <p:grpSpPr>
+        <a:xfrm>
+          <a:off x="0" y="0"/>
+          <a:ext cx="0" cy="0"/>
+          <a:chOff x="0" y="0"/>
+          <a:chExt cx="0" cy="0"/>
+        </a:xfrm>
+      </p:grpSpPr>
+      <p:pic>
+        <p:nvPicPr>
+          <p:cNvPr id="9" name="Picture 8">
+            <a:extLst>
+              <a:ext uri="{FF2B5EF4-FFF2-40B4-BE49-F238E27FC236}">
+                <a16:creationId xmlns:a16="http://schemas.microsoft.com/office/drawing/2014/main" id="{6621A9A8-8D20-3820-6719-6DE43264FE3A}"/>
+              </a:ext>
+            </a:extLst>
+          </p:cNvPr>
+          <p:cNvPicPr>
+            <a:picLocks noChangeAspect="1"/>
+          </p:cNvPicPr>
+          <p:nvPr/>
+        </p:nvPicPr>
+        <p:blipFill>
+          <a:blip r:embed="rId2"/>
+          <a:stretch>
+            <a:fillRect/>
+          </a:stretch>
+        </p:blipFill>
+        <p:spPr>
+          <a:xfrm>
+            <a:off x="2826760" y="716226"/>
+            <a:ext cx="6538480" cy="5425547"/>
+          </a:xfrm>
+          <a:prstGeom prst="rect">
+            <a:avLst/>
+          </a:prstGeom>
+        </p:spPr>
+      </p:pic>
+    </p:spTree>
+    <p:extLst>
+      <p:ext uri="{BB962C8B-B14F-4D97-AF65-F5344CB8AC3E}">
+        <p14:creationId xmlns:p14="http://schemas.microsoft.com/office/powerpoint/2010/main" val="2460135724"/>
+      </p:ext>
+    </p:extLst>
+  </p:cSld>
+  <p:clrMapOvr>
+    <a:masterClrMapping/>
+  </p:clrMapOvr>
+</p:sld>
+</file>
+
+<file path=ppt/slides/slide11.xml><?xml version="1.0" encoding="utf-8"?>
+<p:sld xmlns:a="http://schemas.openxmlformats.org/drawingml/2006/main" xmlns:r="http://schemas.openxmlformats.org/officeDocument/2006/relationships" xmlns:p="http://schemas.openxmlformats.org/presentationml/2006/main">
+  <p:cSld>
+    <p:spTree>
+      <p:nvGrpSpPr>
+        <p:cNvPr id="1" name=""/>
+        <p:cNvGrpSpPr/>
+        <p:nvPr/>
+      </p:nvGrpSpPr>
+      <p:grpSpPr>
+        <a:xfrm>
+          <a:off x="0" y="0"/>
+          <a:ext cx="0" cy="0"/>
+          <a:chOff x="0" y="0"/>
+          <a:chExt cx="0" cy="0"/>
+        </a:xfrm>
+      </p:grpSpPr>
+      <p:sp>
+        <p:nvSpPr>
+          <p:cNvPr id="2" name="Title 1">
+            <a:extLst>
+              <a:ext uri="{FF2B5EF4-FFF2-40B4-BE49-F238E27FC236}">
+                <a16:creationId xmlns:a16="http://schemas.microsoft.com/office/drawing/2014/main" id="{39BC265B-1741-8751-2CDD-647B0811B86F}"/>
+              </a:ext>
+            </a:extLst>
+          </p:cNvPr>
+          <p:cNvSpPr>
+            <a:spLocks noGrp="1"/>
+          </p:cNvSpPr>
+          <p:nvPr>
+            <p:ph type="title"/>
+          </p:nvPr>
+        </p:nvSpPr>
+        <p:spPr>
+          <a:xfrm>
+            <a:off x="1938915" y="2235200"/>
+            <a:ext cx="3932237" cy="542636"/>
+          </a:xfrm>
+        </p:spPr>
+        <p:txBody>
+          <a:bodyPr/>
+          <a:lstStyle/>
+          <a:p>
+            <a:r>
+              <a:rPr lang="en-US" dirty="0"/>
+              <a:t>TRÉNING MODELU</a:t>
+            </a:r>
+          </a:p>
+        </p:txBody>
+      </p:sp>
+      <p:sp>
+        <p:nvSpPr>
+          <p:cNvPr id="4" name="Text Placeholder 3">
+            <a:extLst>
+              <a:ext uri="{FF2B5EF4-FFF2-40B4-BE49-F238E27FC236}">
+                <a16:creationId xmlns:a16="http://schemas.microsoft.com/office/drawing/2014/main" id="{066892C8-C590-7BF7-9293-23C3E33958B5}"/>
+              </a:ext>
+            </a:extLst>
+          </p:cNvPr>
+          <p:cNvSpPr>
+            <a:spLocks noGrp="1"/>
+          </p:cNvSpPr>
+          <p:nvPr>
+            <p:ph type="body" sz="half" idx="2"/>
+          </p:nvPr>
+        </p:nvSpPr>
+        <p:spPr>
+          <a:xfrm>
+            <a:off x="1938915" y="2777836"/>
+            <a:ext cx="3932237" cy="1627909"/>
+          </a:xfrm>
+        </p:spPr>
+        <p:txBody>
+          <a:bodyPr/>
+          <a:lstStyle/>
+          <a:p>
+            <a:r>
+              <a:rPr lang="en-US" dirty="0" err="1"/>
+              <a:t>Postup</a:t>
+            </a:r>
+            <a:r>
+              <a:rPr lang="en-US" dirty="0"/>
+              <a:t> </a:t>
+            </a:r>
+            <a:r>
+              <a:rPr lang="en-US" dirty="0" err="1"/>
+              <a:t>tréningu</a:t>
+            </a:r>
+            <a:r>
+              <a:rPr lang="en-US" dirty="0"/>
+              <a:t>:</a:t>
+            </a:r>
+          </a:p>
+          <a:p>
+            <a:pPr marL="285750" indent="-285750">
+              <a:buFont typeface="Arial" panose="020B0604020202020204" pitchFamily="34" charset="0"/>
+              <a:buChar char="•"/>
+            </a:pPr>
+            <a:r>
+              <a:rPr lang="en-US" dirty="0" err="1">
+                <a:solidFill>
+                  <a:schemeClr val="bg1"/>
+                </a:solidFill>
+              </a:rPr>
+              <a:t>Nahranie</a:t>
+            </a:r>
+            <a:r>
+              <a:rPr lang="en-US" dirty="0">
+                <a:solidFill>
+                  <a:schemeClr val="bg1"/>
+                </a:solidFill>
+              </a:rPr>
+              <a:t> </a:t>
+            </a:r>
+            <a:r>
+              <a:rPr lang="en-US" dirty="0" err="1">
+                <a:solidFill>
+                  <a:schemeClr val="bg1"/>
+                </a:solidFill>
+              </a:rPr>
+              <a:t>dát</a:t>
+            </a:r>
+            <a:endParaRPr lang="en-US" dirty="0">
+              <a:solidFill>
+                <a:schemeClr val="bg1"/>
+              </a:solidFill>
+            </a:endParaRPr>
+          </a:p>
+          <a:p>
+            <a:pPr marL="285750" indent="-285750">
+              <a:buFont typeface="Arial" panose="020B0604020202020204" pitchFamily="34" charset="0"/>
+              <a:buChar char="•"/>
+            </a:pPr>
+            <a:r>
+              <a:rPr lang="en-US" dirty="0" err="1">
+                <a:solidFill>
+                  <a:schemeClr val="bg1"/>
+                </a:solidFill>
+              </a:rPr>
+              <a:t>Rozdelenie</a:t>
+            </a:r>
+            <a:r>
+              <a:rPr lang="en-US" dirty="0">
+                <a:solidFill>
+                  <a:schemeClr val="bg1"/>
+                </a:solidFill>
+              </a:rPr>
+              <a:t> </a:t>
+            </a:r>
+            <a:r>
+              <a:rPr lang="en-US" dirty="0" err="1">
+                <a:solidFill>
+                  <a:schemeClr val="bg1"/>
+                </a:solidFill>
+              </a:rPr>
+              <a:t>na</a:t>
+            </a:r>
+            <a:r>
+              <a:rPr lang="en-US" dirty="0">
+                <a:solidFill>
+                  <a:schemeClr val="bg1"/>
+                </a:solidFill>
+              </a:rPr>
+              <a:t> </a:t>
+            </a:r>
+            <a:r>
+              <a:rPr lang="en-US" dirty="0" err="1">
+                <a:solidFill>
+                  <a:schemeClr val="bg1"/>
+                </a:solidFill>
+              </a:rPr>
+              <a:t>tréningové</a:t>
+            </a:r>
+            <a:r>
+              <a:rPr lang="en-US" dirty="0">
+                <a:solidFill>
+                  <a:schemeClr val="bg1"/>
+                </a:solidFill>
+              </a:rPr>
+              <a:t> a </a:t>
+            </a:r>
+            <a:r>
+              <a:rPr lang="en-US" dirty="0" err="1">
+                <a:solidFill>
+                  <a:schemeClr val="bg1"/>
+                </a:solidFill>
+              </a:rPr>
+              <a:t>evaluačné</a:t>
+            </a:r>
+            <a:r>
+              <a:rPr lang="en-US" dirty="0">
+                <a:solidFill>
+                  <a:schemeClr val="bg1"/>
+                </a:solidFill>
+              </a:rPr>
+              <a:t> </a:t>
+            </a:r>
+            <a:r>
+              <a:rPr lang="en-US" dirty="0" err="1">
+                <a:solidFill>
+                  <a:schemeClr val="bg1"/>
+                </a:solidFill>
+              </a:rPr>
+              <a:t>dáta</a:t>
+            </a:r>
+            <a:endParaRPr lang="en-US" dirty="0">
+              <a:solidFill>
+                <a:schemeClr val="bg1"/>
+              </a:solidFill>
+            </a:endParaRPr>
+          </a:p>
+          <a:p>
+            <a:pPr marL="285750" indent="-285750">
+              <a:buFont typeface="Arial" panose="020B0604020202020204" pitchFamily="34" charset="0"/>
+              <a:buChar char="•"/>
+            </a:pPr>
+            <a:r>
+              <a:rPr lang="en-US" dirty="0" err="1">
+                <a:solidFill>
+                  <a:schemeClr val="bg1"/>
+                </a:solidFill>
+              </a:rPr>
+              <a:t>Natrénovanie</a:t>
+            </a:r>
+            <a:r>
+              <a:rPr lang="en-US" dirty="0">
+                <a:solidFill>
+                  <a:schemeClr val="bg1"/>
+                </a:solidFill>
+              </a:rPr>
+              <a:t> </a:t>
+            </a:r>
+            <a:r>
+              <a:rPr lang="en-US" dirty="0" err="1">
+                <a:solidFill>
+                  <a:schemeClr val="bg1"/>
+                </a:solidFill>
+              </a:rPr>
+              <a:t>modelu</a:t>
+            </a:r>
+            <a:endParaRPr lang="en-US" dirty="0">
+              <a:solidFill>
+                <a:schemeClr val="bg1"/>
+              </a:solidFill>
+            </a:endParaRPr>
+          </a:p>
+        </p:txBody>
+      </p:sp>
+      <p:pic>
+        <p:nvPicPr>
+          <p:cNvPr id="14" name="Picture 13">
+            <a:extLst>
+              <a:ext uri="{FF2B5EF4-FFF2-40B4-BE49-F238E27FC236}">
+                <a16:creationId xmlns:a16="http://schemas.microsoft.com/office/drawing/2014/main" id="{26C7D13F-2157-EB4A-6F5F-A8C80D2FAED0}"/>
+              </a:ext>
+            </a:extLst>
+          </p:cNvPr>
+          <p:cNvPicPr>
+            <a:picLocks noChangeAspect="1"/>
+          </p:cNvPicPr>
+          <p:nvPr/>
+        </p:nvPicPr>
+        <p:blipFill>
+          <a:blip r:embed="rId2"/>
+          <a:stretch>
+            <a:fillRect/>
+          </a:stretch>
+        </p:blipFill>
+        <p:spPr>
+          <a:xfrm>
+            <a:off x="6320850" y="1388918"/>
+            <a:ext cx="4080164" cy="4080164"/>
+          </a:xfrm>
+          <a:prstGeom prst="rect">
+            <a:avLst/>
+          </a:prstGeom>
+        </p:spPr>
+      </p:pic>
+    </p:spTree>
+    <p:extLst>
+      <p:ext uri="{BB962C8B-B14F-4D97-AF65-F5344CB8AC3E}">
+        <p14:creationId xmlns:p14="http://schemas.microsoft.com/office/powerpoint/2010/main" val="3796626015"/>
+      </p:ext>
+    </p:extLst>
+  </p:cSld>
+  <p:clrMapOvr>
+    <a:masterClrMapping/>
+  </p:clrMapOvr>
+</p:sld>
+</file>
+
+<file path=ppt/slides/slide12.xml><?xml version="1.0" encoding="utf-8"?>
+<p:sld xmlns:a="http://schemas.openxmlformats.org/drawingml/2006/main" xmlns:r="http://schemas.openxmlformats.org/officeDocument/2006/relationships" xmlns:p="http://schemas.openxmlformats.org/presentationml/2006/main">
+  <p:cSld>
+    <p:spTree>
+      <p:nvGrpSpPr>
+        <p:cNvPr id="1" name=""/>
+        <p:cNvGrpSpPr/>
+        <p:nvPr/>
+      </p:nvGrpSpPr>
+      <p:grpSpPr>
+        <a:xfrm>
+          <a:off x="0" y="0"/>
+          <a:ext cx="0" cy="0"/>
+          <a:chOff x="0" y="0"/>
+          <a:chExt cx="0" cy="0"/>
+        </a:xfrm>
+      </p:grpSpPr>
+      <p:sp>
+        <p:nvSpPr>
+          <p:cNvPr id="2" name="Title 1">
+            <a:extLst>
+              <a:ext uri="{FF2B5EF4-FFF2-40B4-BE49-F238E27FC236}">
+                <a16:creationId xmlns:a16="http://schemas.microsoft.com/office/drawing/2014/main" id="{EBCA7F30-3CA0-754F-1A99-2F93DCF8FB3D}"/>
+              </a:ext>
+            </a:extLst>
+          </p:cNvPr>
+          <p:cNvSpPr>
+            <a:spLocks noGrp="1"/>
+          </p:cNvSpPr>
+          <p:nvPr>
+            <p:ph type="title"/>
+          </p:nvPr>
+        </p:nvSpPr>
+        <p:spPr>
+          <a:xfrm>
+            <a:off x="1148846" y="2124589"/>
+            <a:ext cx="4064000" cy="579582"/>
+          </a:xfrm>
+        </p:spPr>
+        <p:txBody>
+          <a:bodyPr/>
+          <a:lstStyle/>
+          <a:p>
+            <a:r>
+              <a:rPr lang="en-US" dirty="0"/>
+              <a:t>VÝSLEDKY MODELU</a:t>
+            </a:r>
+          </a:p>
+        </p:txBody>
+      </p:sp>
+      <p:sp>
+        <p:nvSpPr>
+          <p:cNvPr id="4" name="Text Placeholder 3">
+            <a:extLst>
+              <a:ext uri="{FF2B5EF4-FFF2-40B4-BE49-F238E27FC236}">
+                <a16:creationId xmlns:a16="http://schemas.microsoft.com/office/drawing/2014/main" id="{67616329-CA3F-CF11-EE4C-32C6D097B7EB}"/>
+              </a:ext>
+            </a:extLst>
+          </p:cNvPr>
+          <p:cNvSpPr>
+            <a:spLocks noGrp="1"/>
+          </p:cNvSpPr>
+          <p:nvPr>
+            <p:ph type="body" sz="half" idx="2"/>
+          </p:nvPr>
+        </p:nvSpPr>
+        <p:spPr>
+          <a:xfrm>
+            <a:off x="1235870" y="2704171"/>
+            <a:ext cx="3848389" cy="2468418"/>
+          </a:xfrm>
+        </p:spPr>
+        <p:txBody>
+          <a:bodyPr/>
+          <a:lstStyle/>
+          <a:p>
+            <a:r>
+              <a:rPr lang="en-US" dirty="0">
+                <a:solidFill>
+                  <a:schemeClr val="bg1"/>
+                </a:solidFill>
+              </a:rPr>
+              <a:t>Model </a:t>
+            </a:r>
+            <a:r>
+              <a:rPr lang="en-US" dirty="0" err="1">
+                <a:solidFill>
+                  <a:schemeClr val="bg1"/>
+                </a:solidFill>
+              </a:rPr>
+              <a:t>správne</a:t>
+            </a:r>
+            <a:r>
+              <a:rPr lang="en-US" dirty="0">
+                <a:solidFill>
+                  <a:schemeClr val="bg1"/>
+                </a:solidFill>
+              </a:rPr>
+              <a:t> </a:t>
+            </a:r>
+            <a:r>
+              <a:rPr lang="en-US" dirty="0" err="1">
+                <a:solidFill>
+                  <a:schemeClr val="bg1"/>
+                </a:solidFill>
+              </a:rPr>
+              <a:t>vyhodnotil</a:t>
+            </a:r>
+            <a:r>
+              <a:rPr lang="en-US" dirty="0">
+                <a:solidFill>
+                  <a:schemeClr val="bg1"/>
+                </a:solidFill>
+              </a:rPr>
+              <a:t> </a:t>
+            </a:r>
+            <a:r>
+              <a:rPr lang="en-US" dirty="0"/>
+              <a:t>68%</a:t>
+            </a:r>
+            <a:r>
+              <a:rPr lang="en-US" dirty="0">
+                <a:solidFill>
+                  <a:schemeClr val="bg1"/>
+                </a:solidFill>
+              </a:rPr>
+              <a:t> </a:t>
+            </a:r>
+            <a:r>
+              <a:rPr lang="en-US" dirty="0" err="1">
+                <a:solidFill>
+                  <a:schemeClr val="bg1"/>
+                </a:solidFill>
+              </a:rPr>
+              <a:t>prípadov</a:t>
+            </a:r>
+            <a:r>
+              <a:rPr lang="en-US" dirty="0">
+                <a:solidFill>
+                  <a:schemeClr val="bg1"/>
+                </a:solidFill>
+              </a:rPr>
+              <a:t> </a:t>
+            </a:r>
+            <a:r>
+              <a:rPr lang="en-US" dirty="0" err="1"/>
+              <a:t>úmrtia</a:t>
+            </a:r>
+            <a:r>
+              <a:rPr lang="en-US" dirty="0">
+                <a:solidFill>
+                  <a:schemeClr val="bg1"/>
+                </a:solidFill>
+              </a:rPr>
+              <a:t> a </a:t>
+            </a:r>
+            <a:r>
+              <a:rPr lang="en-US" dirty="0"/>
+              <a:t>81% </a:t>
+            </a:r>
+            <a:r>
+              <a:rPr lang="en-US" dirty="0" err="1"/>
+              <a:t>prežitia</a:t>
+            </a:r>
+            <a:r>
+              <a:rPr lang="en-US" dirty="0">
+                <a:solidFill>
+                  <a:schemeClr val="bg1"/>
+                </a:solidFill>
+              </a:rPr>
+              <a:t> </a:t>
+            </a:r>
+            <a:r>
+              <a:rPr lang="en-US" dirty="0" err="1">
+                <a:solidFill>
+                  <a:schemeClr val="bg1"/>
+                </a:solidFill>
+              </a:rPr>
+              <a:t>srdcového</a:t>
+            </a:r>
+            <a:r>
+              <a:rPr lang="en-US" dirty="0">
+                <a:solidFill>
+                  <a:schemeClr val="bg1"/>
+                </a:solidFill>
+              </a:rPr>
+              <a:t> </a:t>
+            </a:r>
+            <a:r>
+              <a:rPr lang="en-US" dirty="0" err="1">
+                <a:solidFill>
+                  <a:schemeClr val="bg1"/>
+                </a:solidFill>
+              </a:rPr>
+              <a:t>zlyhania</a:t>
+            </a:r>
+            <a:r>
+              <a:rPr lang="en-US" dirty="0">
+                <a:solidFill>
+                  <a:schemeClr val="bg1"/>
+                </a:solidFill>
+              </a:rPr>
+              <a:t>.</a:t>
+            </a:r>
+          </a:p>
+          <a:p>
+            <a:endParaRPr lang="en-US" dirty="0">
+              <a:solidFill>
+                <a:schemeClr val="bg1"/>
+              </a:solidFill>
+            </a:endParaRPr>
+          </a:p>
+          <a:p>
+            <a:r>
+              <a:rPr lang="en-US" dirty="0">
+                <a:solidFill>
+                  <a:schemeClr val="bg1"/>
+                </a:solidFill>
+              </a:rPr>
+              <a:t>Pri </a:t>
+            </a:r>
+            <a:r>
+              <a:rPr lang="en-US" dirty="0" err="1">
+                <a:solidFill>
+                  <a:schemeClr val="bg1"/>
+                </a:solidFill>
+              </a:rPr>
+              <a:t>vyhodnocovaní</a:t>
+            </a:r>
+            <a:r>
+              <a:rPr lang="en-US" dirty="0">
+                <a:solidFill>
+                  <a:schemeClr val="bg1"/>
+                </a:solidFill>
+              </a:rPr>
+              <a:t> </a:t>
+            </a:r>
+            <a:r>
+              <a:rPr lang="en-US" dirty="0" err="1">
+                <a:solidFill>
+                  <a:schemeClr val="bg1"/>
+                </a:solidFill>
+              </a:rPr>
+              <a:t>modelu</a:t>
+            </a:r>
+            <a:r>
+              <a:rPr lang="en-US" dirty="0">
+                <a:solidFill>
+                  <a:schemeClr val="bg1"/>
+                </a:solidFill>
+              </a:rPr>
+              <a:t> </a:t>
+            </a:r>
+            <a:r>
+              <a:rPr lang="en-US" dirty="0" err="1">
+                <a:solidFill>
+                  <a:schemeClr val="bg1"/>
+                </a:solidFill>
+              </a:rPr>
+              <a:t>boli</a:t>
+            </a:r>
+            <a:r>
+              <a:rPr lang="en-US" dirty="0">
+                <a:solidFill>
+                  <a:schemeClr val="bg1"/>
+                </a:solidFill>
+              </a:rPr>
+              <a:t> </a:t>
+            </a:r>
+            <a:r>
+              <a:rPr lang="en-US" dirty="0" err="1">
+                <a:solidFill>
+                  <a:schemeClr val="bg1"/>
+                </a:solidFill>
+              </a:rPr>
+              <a:t>uprednostnené</a:t>
+            </a:r>
+            <a:r>
+              <a:rPr lang="en-US" dirty="0">
+                <a:solidFill>
+                  <a:schemeClr val="bg1"/>
+                </a:solidFill>
+              </a:rPr>
+              <a:t> </a:t>
+            </a:r>
+            <a:r>
+              <a:rPr lang="en-US" dirty="0" err="1">
+                <a:solidFill>
+                  <a:schemeClr val="bg1"/>
+                </a:solidFill>
+              </a:rPr>
+              <a:t>metriky</a:t>
+            </a:r>
+            <a:r>
+              <a:rPr lang="en-US" dirty="0">
+                <a:solidFill>
+                  <a:schemeClr val="bg1"/>
+                </a:solidFill>
+              </a:rPr>
+              <a:t> </a:t>
+            </a:r>
+            <a:r>
+              <a:rPr lang="en-US" dirty="0"/>
+              <a:t>Recall</a:t>
+            </a:r>
+            <a:r>
+              <a:rPr lang="en-US" dirty="0">
+                <a:solidFill>
+                  <a:schemeClr val="bg1"/>
+                </a:solidFill>
+              </a:rPr>
+              <a:t> a </a:t>
+            </a:r>
+            <a:r>
+              <a:rPr lang="en-US" dirty="0"/>
+              <a:t>F1 score</a:t>
+            </a:r>
+            <a:r>
+              <a:rPr lang="en-US" dirty="0">
+                <a:solidFill>
+                  <a:schemeClr val="bg1"/>
+                </a:solidFill>
+              </a:rPr>
+              <a:t>, </a:t>
+            </a:r>
+            <a:r>
+              <a:rPr lang="en-US" dirty="0" err="1">
+                <a:solidFill>
+                  <a:schemeClr val="bg1"/>
+                </a:solidFill>
+              </a:rPr>
+              <a:t>ktoré</a:t>
+            </a:r>
+            <a:r>
+              <a:rPr lang="en-US" dirty="0">
+                <a:solidFill>
+                  <a:schemeClr val="bg1"/>
+                </a:solidFill>
+              </a:rPr>
+              <a:t> </a:t>
+            </a:r>
+            <a:r>
+              <a:rPr lang="en-US" dirty="0" err="1">
+                <a:solidFill>
+                  <a:schemeClr val="bg1"/>
+                </a:solidFill>
+              </a:rPr>
+              <a:t>dávajú</a:t>
+            </a:r>
+            <a:r>
+              <a:rPr lang="en-US" dirty="0">
+                <a:solidFill>
+                  <a:schemeClr val="bg1"/>
+                </a:solidFill>
+              </a:rPr>
+              <a:t> </a:t>
+            </a:r>
+            <a:r>
+              <a:rPr lang="en-US" dirty="0" err="1">
+                <a:solidFill>
+                  <a:schemeClr val="bg1"/>
+                </a:solidFill>
+              </a:rPr>
+              <a:t>dôraz</a:t>
+            </a:r>
+            <a:r>
+              <a:rPr lang="en-US" dirty="0">
+                <a:solidFill>
+                  <a:schemeClr val="bg1"/>
+                </a:solidFill>
+              </a:rPr>
+              <a:t> </a:t>
+            </a:r>
+            <a:r>
+              <a:rPr lang="en-US" dirty="0" err="1">
+                <a:solidFill>
+                  <a:schemeClr val="bg1"/>
+                </a:solidFill>
+              </a:rPr>
+              <a:t>na</a:t>
+            </a:r>
+            <a:r>
+              <a:rPr lang="en-US" dirty="0">
+                <a:solidFill>
+                  <a:schemeClr val="bg1"/>
+                </a:solidFill>
+              </a:rPr>
+              <a:t> model, aby </a:t>
+            </a:r>
+            <a:r>
+              <a:rPr lang="en-US" dirty="0" err="1">
+                <a:solidFill>
+                  <a:schemeClr val="bg1"/>
+                </a:solidFill>
+              </a:rPr>
+              <a:t>predikoval</a:t>
+            </a:r>
+            <a:r>
+              <a:rPr lang="en-US" dirty="0">
+                <a:solidFill>
+                  <a:schemeClr val="bg1"/>
+                </a:solidFill>
+              </a:rPr>
+              <a:t> </a:t>
+            </a:r>
+            <a:r>
+              <a:rPr lang="en-US" dirty="0" err="1">
+                <a:solidFill>
+                  <a:schemeClr val="bg1"/>
+                </a:solidFill>
+              </a:rPr>
+              <a:t>pacientské</a:t>
+            </a:r>
+            <a:r>
+              <a:rPr lang="en-US" dirty="0">
+                <a:solidFill>
+                  <a:schemeClr val="bg1"/>
+                </a:solidFill>
+              </a:rPr>
+              <a:t> </a:t>
+            </a:r>
+            <a:r>
+              <a:rPr lang="en-US" dirty="0" err="1">
+                <a:solidFill>
+                  <a:schemeClr val="bg1"/>
+                </a:solidFill>
+              </a:rPr>
+              <a:t>úmrtia</a:t>
+            </a:r>
+            <a:r>
+              <a:rPr lang="en-US" dirty="0">
+                <a:solidFill>
+                  <a:schemeClr val="bg1"/>
+                </a:solidFill>
+              </a:rPr>
+              <a:t> </a:t>
+            </a:r>
+            <a:r>
+              <a:rPr lang="en-US" dirty="0" err="1">
+                <a:solidFill>
+                  <a:schemeClr val="bg1"/>
+                </a:solidFill>
+              </a:rPr>
+              <a:t>častejšie</a:t>
+            </a:r>
+            <a:r>
+              <a:rPr lang="en-US" dirty="0">
+                <a:solidFill>
+                  <a:schemeClr val="bg1"/>
+                </a:solidFill>
+              </a:rPr>
+              <a:t>.</a:t>
+            </a:r>
+          </a:p>
+        </p:txBody>
+      </p:sp>
+      <p:pic>
+        <p:nvPicPr>
+          <p:cNvPr id="8" name="Picture 7">
+            <a:extLst>
+              <a:ext uri="{FF2B5EF4-FFF2-40B4-BE49-F238E27FC236}">
+                <a16:creationId xmlns:a16="http://schemas.microsoft.com/office/drawing/2014/main" id="{F7415838-0B9C-4063-50A7-E56B7EAB7FE7}"/>
+              </a:ext>
+            </a:extLst>
+          </p:cNvPr>
+          <p:cNvPicPr>
+            <a:picLocks noChangeAspect="1"/>
+          </p:cNvPicPr>
+          <p:nvPr/>
+        </p:nvPicPr>
+        <p:blipFill>
+          <a:blip r:embed="rId2"/>
+          <a:stretch>
+            <a:fillRect/>
+          </a:stretch>
+        </p:blipFill>
+        <p:spPr>
+          <a:xfrm>
+            <a:off x="5541961" y="1110541"/>
+            <a:ext cx="5810251" cy="4636918"/>
+          </a:xfrm>
+          <a:prstGeom prst="rect">
+            <a:avLst/>
+          </a:prstGeom>
+          <a:ln w="76200">
+            <a:solidFill>
+              <a:schemeClr val="tx1"/>
+            </a:solidFill>
+          </a:ln>
+          <a:effectLst>
+            <a:outerShdw blurRad="63500" sx="102000" sy="102000" algn="ctr" rotWithShape="0">
+              <a:prstClr val="black">
+                <a:alpha val="40000"/>
+              </a:prstClr>
+            </a:outerShdw>
+          </a:effectLst>
+        </p:spPr>
+      </p:pic>
+    </p:spTree>
+    <p:extLst>
+      <p:ext uri="{BB962C8B-B14F-4D97-AF65-F5344CB8AC3E}">
+        <p14:creationId xmlns:p14="http://schemas.microsoft.com/office/powerpoint/2010/main" val="1314427167"/>
+      </p:ext>
+    </p:extLst>
+  </p:cSld>
+  <p:clrMapOvr>
+    <a:masterClrMapping/>
+  </p:clrMapOvr>
+</p:sld>
+</file>
+
+<file path=ppt/slides/slide13.xml><?xml version="1.0" encoding="utf-8"?>
+<p:sld xmlns:a="http://schemas.openxmlformats.org/drawingml/2006/main" xmlns:r="http://schemas.openxmlformats.org/officeDocument/2006/relationships" xmlns:p="http://schemas.openxmlformats.org/presentationml/2006/main">
+  <p:cSld>
+    <p:spTree>
+      <p:nvGrpSpPr>
+        <p:cNvPr id="1" name=""/>
+        <p:cNvGrpSpPr/>
+        <p:nvPr/>
+      </p:nvGrpSpPr>
+      <p:grpSpPr>
+        <a:xfrm>
+          <a:off x="0" y="0"/>
+          <a:ext cx="0" cy="0"/>
+          <a:chOff x="0" y="0"/>
+          <a:chExt cx="0" cy="0"/>
+        </a:xfrm>
+      </p:grpSpPr>
+      <p:sp>
+        <p:nvSpPr>
+          <p:cNvPr id="2" name="Title 1">
+            <a:extLst>
+              <a:ext uri="{FF2B5EF4-FFF2-40B4-BE49-F238E27FC236}">
+                <a16:creationId xmlns:a16="http://schemas.microsoft.com/office/drawing/2014/main" id="{019D783B-171C-705C-C57E-ACD5E515CCD7}"/>
+              </a:ext>
+            </a:extLst>
+          </p:cNvPr>
+          <p:cNvSpPr>
+            <a:spLocks noGrp="1"/>
+          </p:cNvSpPr>
+          <p:nvPr>
+            <p:ph type="title"/>
+          </p:nvPr>
+        </p:nvSpPr>
+        <p:spPr/>
+        <p:txBody>
+          <a:bodyPr/>
+          <a:lstStyle/>
+          <a:p>
+            <a:pPr algn="ctr"/>
+            <a:r>
+              <a:rPr lang="en-US" dirty="0">
+                <a:latin typeface="Clother Black" pitchFamily="2" charset="-79"/>
+                <a:cs typeface="Clother Black" pitchFamily="2" charset="-79"/>
+              </a:rPr>
+              <a:t>ZDROJE</a:t>
+            </a:r>
+          </a:p>
+        </p:txBody>
+      </p:sp>
+      <p:sp>
+        <p:nvSpPr>
+          <p:cNvPr id="3" name="Content Placeholder 2">
+            <a:extLst>
+              <a:ext uri="{FF2B5EF4-FFF2-40B4-BE49-F238E27FC236}">
+                <a16:creationId xmlns:a16="http://schemas.microsoft.com/office/drawing/2014/main" id="{F3A00795-775B-3253-F80E-A353A057808B}"/>
+              </a:ext>
+            </a:extLst>
+          </p:cNvPr>
+          <p:cNvSpPr>
+            <a:spLocks noGrp="1"/>
+          </p:cNvSpPr>
+          <p:nvPr>
+            <p:ph idx="1"/>
+          </p:nvPr>
+        </p:nvSpPr>
+        <p:spPr/>
+        <p:txBody>
+          <a:bodyPr>
+            <a:normAutofit/>
+          </a:bodyPr>
+          <a:lstStyle/>
+          <a:p>
+            <a:r>
+              <a:rPr lang="en-US" sz="1800" baseline="30000" dirty="0"/>
+              <a:t>1</a:t>
+            </a:r>
+            <a:r>
+              <a:rPr lang="en-US" sz="1800" dirty="0"/>
+              <a:t> </a:t>
+            </a:r>
+            <a:r>
+              <a:rPr lang="en-US" sz="1800" dirty="0">
+                <a:solidFill>
+                  <a:schemeClr val="bg1"/>
+                </a:solidFill>
+              </a:rPr>
+              <a:t>Heart Failure Clinical Records [Dataset]. (2020). UCI Machine Learning Repository. </a:t>
+            </a:r>
+            <a:r>
+              <a:rPr lang="en-US" sz="1800" dirty="0">
+                <a:solidFill>
+                  <a:schemeClr val="bg1"/>
+                </a:solidFill>
+                <a:hlinkClick r:id="rId2">
+                  <a:extLst>
+                    <a:ext uri="{A12FA001-AC4F-418D-AE19-62706E023703}">
+                      <ahyp:hlinkClr xmlns:ahyp="http://schemas.microsoft.com/office/drawing/2018/hyperlinkcolor" val="tx"/>
+                    </a:ext>
+                  </a:extLst>
+                </a:hlinkClick>
+              </a:rPr>
+              <a:t>https://doi.org/10.24432/C5Z89R</a:t>
+            </a:r>
+            <a:r>
+              <a:rPr lang="en-US" sz="1800" dirty="0">
+                <a:solidFill>
+                  <a:schemeClr val="bg1"/>
+                </a:solidFill>
+              </a:rPr>
+              <a:t>.</a:t>
+            </a:r>
+          </a:p>
+          <a:p>
+            <a:r>
+              <a:rPr lang="en-US" sz="1800" baseline="30000" dirty="0"/>
+              <a:t>2</a:t>
+            </a:r>
+            <a:r>
+              <a:rPr lang="en-US" sz="1800" dirty="0">
+                <a:solidFill>
+                  <a:schemeClr val="bg1"/>
+                </a:solidFill>
+              </a:rPr>
+              <a:t> Chicco, D., Jurman, G. Machine learning can predict survival of patients with heart failure from serum creatinine and ejection fraction alone. </a:t>
+            </a:r>
+            <a:r>
+              <a:rPr lang="en-US" sz="1800" i="1" dirty="0">
+                <a:solidFill>
+                  <a:schemeClr val="bg1"/>
+                </a:solidFill>
+              </a:rPr>
+              <a:t>BMC Med Inform </a:t>
+            </a:r>
+            <a:r>
+              <a:rPr lang="en-US" sz="1800" i="1" dirty="0" err="1">
+                <a:solidFill>
+                  <a:schemeClr val="bg1"/>
+                </a:solidFill>
+              </a:rPr>
+              <a:t>Decis</a:t>
+            </a:r>
+            <a:r>
+              <a:rPr lang="en-US" sz="1800" i="1" dirty="0">
+                <a:solidFill>
+                  <a:schemeClr val="bg1"/>
+                </a:solidFill>
+              </a:rPr>
+              <a:t> Mak</a:t>
+            </a:r>
+            <a:r>
+              <a:rPr lang="en-US" sz="1800" dirty="0">
+                <a:solidFill>
+                  <a:schemeClr val="bg1"/>
+                </a:solidFill>
+              </a:rPr>
+              <a:t> </a:t>
+            </a:r>
+            <a:r>
+              <a:rPr lang="en-US" sz="1800" b="1" dirty="0">
+                <a:solidFill>
+                  <a:schemeClr val="bg1"/>
+                </a:solidFill>
+              </a:rPr>
+              <a:t>20</a:t>
+            </a:r>
+            <a:r>
+              <a:rPr lang="en-US" sz="1800" dirty="0">
+                <a:solidFill>
+                  <a:schemeClr val="bg1"/>
+                </a:solidFill>
+              </a:rPr>
+              <a:t>, 16 (2020). </a:t>
+            </a:r>
+            <a:r>
+              <a:rPr lang="en-US" sz="1800" dirty="0">
+                <a:solidFill>
+                  <a:schemeClr val="bg1"/>
+                </a:solidFill>
+                <a:hlinkClick r:id="rId3">
+                  <a:extLst>
+                    <a:ext uri="{A12FA001-AC4F-418D-AE19-62706E023703}">
+                      <ahyp:hlinkClr xmlns:ahyp="http://schemas.microsoft.com/office/drawing/2018/hyperlinkcolor" val="tx"/>
+                    </a:ext>
+                  </a:extLst>
+                </a:hlinkClick>
+              </a:rPr>
+              <a:t>https://</a:t>
+            </a:r>
+            <a:r>
+              <a:rPr lang="en-US" sz="1800" dirty="0" err="1">
+                <a:solidFill>
+                  <a:schemeClr val="bg1"/>
+                </a:solidFill>
+                <a:hlinkClick r:id="rId3">
+                  <a:extLst>
+                    <a:ext uri="{A12FA001-AC4F-418D-AE19-62706E023703}">
+                      <ahyp:hlinkClr xmlns:ahyp="http://schemas.microsoft.com/office/drawing/2018/hyperlinkcolor" val="tx"/>
+                    </a:ext>
+                  </a:extLst>
+                </a:hlinkClick>
+              </a:rPr>
+              <a:t>doi.org</a:t>
+            </a:r>
+            <a:r>
+              <a:rPr lang="en-US" sz="1800" dirty="0">
+                <a:solidFill>
+                  <a:schemeClr val="bg1"/>
+                </a:solidFill>
+                <a:hlinkClick r:id="rId3">
+                  <a:extLst>
+                    <a:ext uri="{A12FA001-AC4F-418D-AE19-62706E023703}">
+                      <ahyp:hlinkClr xmlns:ahyp="http://schemas.microsoft.com/office/drawing/2018/hyperlinkcolor" val="tx"/>
+                    </a:ext>
+                  </a:extLst>
+                </a:hlinkClick>
+              </a:rPr>
+              <a:t>/10.1186/s12911-020-1023-5</a:t>
+            </a:r>
+            <a:endParaRPr lang="en-US" sz="1800" dirty="0">
+              <a:solidFill>
+                <a:schemeClr val="bg1"/>
+              </a:solidFill>
+            </a:endParaRPr>
+          </a:p>
+        </p:txBody>
+      </p:sp>
+    </p:spTree>
+    <p:extLst>
+      <p:ext uri="{BB962C8B-B14F-4D97-AF65-F5344CB8AC3E}">
+        <p14:creationId xmlns:p14="http://schemas.microsoft.com/office/powerpoint/2010/main" val="2478960068"/>
+      </p:ext>
+    </p:extLst>
+  </p:cSld>
+  <p:clrMapOvr>
+    <a:masterClrMapping/>
+  </p:clrMapOvr>
+</p:sld>
+</file>
+
+<file path=ppt/slides/slide14.xml><?xml version="1.0" encoding="utf-8"?>
+<p:sld xmlns:a="http://schemas.openxmlformats.org/drawingml/2006/main" xmlns:r="http://schemas.openxmlformats.org/officeDocument/2006/relationships" xmlns:p="http://schemas.openxmlformats.org/presentationml/2006/main">
+  <p:cSld>
+    <p:spTree>
+      <p:nvGrpSpPr>
+        <p:cNvPr id="1" name="">
+          <a:extLst>
+            <a:ext uri="{FF2B5EF4-FFF2-40B4-BE49-F238E27FC236}">
+              <a16:creationId xmlns:a16="http://schemas.microsoft.com/office/drawing/2014/main" id="{2880BD2E-6CDC-922A-5ABF-EC9F463DE713}"/>
+            </a:ext>
+          </a:extLst>
+        </p:cNvPr>
+        <p:cNvGrpSpPr/>
+        <p:nvPr/>
+      </p:nvGrpSpPr>
+      <p:grpSpPr>
+        <a:xfrm>
+          <a:off x="0" y="0"/>
+          <a:ext cx="0" cy="0"/>
+          <a:chOff x="0" y="0"/>
+          <a:chExt cx="0" cy="0"/>
+        </a:xfrm>
+      </p:grpSpPr>
+      <p:pic>
+        <p:nvPicPr>
+          <p:cNvPr id="4" name="Picture 3">
+            <a:extLst>
+              <a:ext uri="{FF2B5EF4-FFF2-40B4-BE49-F238E27FC236}">
+                <a16:creationId xmlns:a16="http://schemas.microsoft.com/office/drawing/2014/main" id="{99FECBC2-EA38-2D6B-EBC9-A9AD5FA929FC}"/>
+              </a:ext>
+            </a:extLst>
+          </p:cNvPr>
+          <p:cNvPicPr>
+            <a:picLocks noChangeAspect="1"/>
+          </p:cNvPicPr>
+          <p:nvPr/>
+        </p:nvPicPr>
+        <p:blipFill>
+          <a:blip r:embed="rId2"/>
+          <a:stretch>
+            <a:fillRect/>
+          </a:stretch>
+        </p:blipFill>
+        <p:spPr>
+          <a:xfrm>
+            <a:off x="118946" y="66907"/>
+            <a:ext cx="11954107" cy="6724185"/>
+          </a:xfrm>
+          <a:prstGeom prst="rect">
+            <a:avLst/>
+          </a:prstGeom>
+        </p:spPr>
+      </p:pic>
+      <p:sp>
+        <p:nvSpPr>
+          <p:cNvPr id="2" name="Title 1">
+            <a:extLst>
+              <a:ext uri="{FF2B5EF4-FFF2-40B4-BE49-F238E27FC236}">
+                <a16:creationId xmlns:a16="http://schemas.microsoft.com/office/drawing/2014/main" id="{86D06C93-3A0F-279C-8E6C-E96DF7DDF4F3}"/>
+              </a:ext>
+            </a:extLst>
+          </p:cNvPr>
+          <p:cNvSpPr>
+            <a:spLocks noGrp="1"/>
+          </p:cNvSpPr>
+          <p:nvPr>
+            <p:ph type="ctrTitle"/>
+          </p:nvPr>
+        </p:nvSpPr>
+        <p:spPr>
+          <a:xfrm>
+            <a:off x="136480" y="4594301"/>
+            <a:ext cx="9144000" cy="1365431"/>
+          </a:xfrm>
+        </p:spPr>
+        <p:txBody>
+          <a:bodyPr>
+            <a:normAutofit/>
+          </a:bodyPr>
+          <a:lstStyle/>
+          <a:p>
+            <a:r>
+              <a:rPr lang="sk-SK" sz="4000" noProof="0" dirty="0">
+                <a:latin typeface="Clother Black" pitchFamily="2" charset="-79"/>
+                <a:cs typeface="Clother Black" pitchFamily="2" charset="-79"/>
+              </a:rPr>
+              <a:t>Predikcia úmrtnosti pacientov s diagnostikovaným zlyhaním srdca</a:t>
+            </a:r>
+          </a:p>
+        </p:txBody>
+      </p:sp>
+      <p:sp>
+        <p:nvSpPr>
+          <p:cNvPr id="3" name="Subtitle 2">
+            <a:extLst>
+              <a:ext uri="{FF2B5EF4-FFF2-40B4-BE49-F238E27FC236}">
+                <a16:creationId xmlns:a16="http://schemas.microsoft.com/office/drawing/2014/main" id="{67CF961E-A49A-5C72-7E48-C6FB39B9B7B2}"/>
+              </a:ext>
+            </a:extLst>
+          </p:cNvPr>
+          <p:cNvSpPr>
+            <a:spLocks noGrp="1"/>
+          </p:cNvSpPr>
+          <p:nvPr>
+            <p:ph type="subTitle" idx="1"/>
+          </p:nvPr>
+        </p:nvSpPr>
+        <p:spPr/>
+        <p:txBody>
+          <a:bodyPr/>
+          <a:lstStyle/>
+          <a:p>
+            <a:r>
+              <a:rPr lang="sk-SK" b="1" noProof="0" dirty="0"/>
+              <a:t>Maximilián Cenkner</a:t>
+            </a:r>
+          </a:p>
+        </p:txBody>
+      </p:sp>
+    </p:spTree>
+    <p:extLst>
+      <p:ext uri="{BB962C8B-B14F-4D97-AF65-F5344CB8AC3E}">
+        <p14:creationId xmlns:p14="http://schemas.microsoft.com/office/powerpoint/2010/main" val="1065602193"/>
       </p:ext>
     </p:extLst>
   </p:cSld>
@@ -2485,7 +3723,10 @@
           <a:lstStyle/>
           <a:p>
             <a:r>
-              <a:rPr lang="sk-SK" noProof="0" dirty="0"/>
+              <a:rPr lang="sk-SK" b="0" noProof="0" dirty="0">
+                <a:latin typeface="Clother Black" pitchFamily="2" charset="-79"/>
+                <a:cs typeface="Clother Black" pitchFamily="2" charset="-79"/>
+              </a:rPr>
               <a:t>OBSAH PRÁCE</a:t>
             </a:r>
           </a:p>
@@ -2514,6 +3755,12 @@
           <a:p>
             <a:r>
               <a:rPr lang="sk-SK" b="1" noProof="0" dirty="0"/>
+              <a:t>Fungovanie srdca</a:t>
+            </a:r>
+          </a:p>
+          <a:p>
+            <a:r>
+              <a:rPr lang="sk-SK" b="1" noProof="0" dirty="0"/>
               <a:t>Čo sú </a:t>
             </a:r>
             <a:r>
@@ -2578,18 +3825,7 @@
           <a:p>
             <a:r>
               <a:rPr lang="sk-SK" b="1" noProof="0" dirty="0"/>
-              <a:t>Ako prebieha tréning a </a:t>
-            </a:r>
-            <a:r>
-              <a:rPr lang="sk-SK" b="1" noProof="0" dirty="0" err="1"/>
-              <a:t>evaluácia</a:t>
-            </a:r>
-            <a:endParaRPr lang="sk-SK" b="1" noProof="0" dirty="0"/>
-          </a:p>
-          <a:p>
-            <a:r>
-              <a:rPr lang="sk-SK" b="1" noProof="0" dirty="0"/>
-              <a:t>Finálny experiment</a:t>
+              <a:t>Tréning modelu</a:t>
             </a:r>
           </a:p>
           <a:p>
@@ -2614,6 +3850,332 @@
 </file>
 
 <file path=ppt/slides/slide3.xml><?xml version="1.0" encoding="utf-8"?>
+<p:sld xmlns:a="http://schemas.openxmlformats.org/drawingml/2006/main" xmlns:r="http://schemas.openxmlformats.org/officeDocument/2006/relationships" xmlns:p="http://schemas.openxmlformats.org/presentationml/2006/main">
+  <p:cSld>
+    <p:spTree>
+      <p:nvGrpSpPr>
+        <p:cNvPr id="1" name=""/>
+        <p:cNvGrpSpPr/>
+        <p:nvPr/>
+      </p:nvGrpSpPr>
+      <p:grpSpPr>
+        <a:xfrm>
+          <a:off x="0" y="0"/>
+          <a:ext cx="0" cy="0"/>
+          <a:chOff x="0" y="0"/>
+          <a:chExt cx="0" cy="0"/>
+        </a:xfrm>
+      </p:grpSpPr>
+      <p:sp>
+        <p:nvSpPr>
+          <p:cNvPr id="2" name="Title 1">
+            <a:extLst>
+              <a:ext uri="{FF2B5EF4-FFF2-40B4-BE49-F238E27FC236}">
+                <a16:creationId xmlns:a16="http://schemas.microsoft.com/office/drawing/2014/main" id="{ACA049D2-4087-E546-F8FB-F2DFE2DFAC6E}"/>
+              </a:ext>
+            </a:extLst>
+          </p:cNvPr>
+          <p:cNvSpPr>
+            <a:spLocks noGrp="1"/>
+          </p:cNvSpPr>
+          <p:nvPr>
+            <p:ph type="title"/>
+          </p:nvPr>
+        </p:nvSpPr>
+        <p:spPr/>
+        <p:txBody>
+          <a:bodyPr/>
+          <a:lstStyle/>
+          <a:p>
+            <a:r>
+              <a:rPr lang="en-US" dirty="0"/>
+              <a:t>ZLYHANIE SRDCA</a:t>
+            </a:r>
+          </a:p>
+        </p:txBody>
+      </p:sp>
+      <p:sp>
+        <p:nvSpPr>
+          <p:cNvPr id="4" name="Text Placeholder 3">
+            <a:extLst>
+              <a:ext uri="{FF2B5EF4-FFF2-40B4-BE49-F238E27FC236}">
+                <a16:creationId xmlns:a16="http://schemas.microsoft.com/office/drawing/2014/main" id="{A62B4667-F495-2F6F-86D0-B4C83EB07F6F}"/>
+              </a:ext>
+            </a:extLst>
+          </p:cNvPr>
+          <p:cNvSpPr>
+            <a:spLocks noGrp="1"/>
+          </p:cNvSpPr>
+          <p:nvPr>
+            <p:ph type="body" sz="half" idx="2"/>
+          </p:nvPr>
+        </p:nvSpPr>
+        <p:spPr/>
+        <p:txBody>
+          <a:bodyPr/>
+          <a:lstStyle/>
+          <a:p>
+            <a:r>
+              <a:rPr lang="en-US" dirty="0" err="1"/>
+              <a:t>Neschopnosť</a:t>
+            </a:r>
+            <a:r>
+              <a:rPr lang="en-US" dirty="0"/>
+              <a:t> </a:t>
+            </a:r>
+            <a:r>
+              <a:rPr lang="en-US" dirty="0" err="1"/>
+              <a:t>srdca</a:t>
+            </a:r>
+            <a:r>
+              <a:rPr lang="en-US" dirty="0"/>
+              <a:t> </a:t>
+            </a:r>
+            <a:r>
+              <a:rPr lang="en-US" dirty="0" err="1"/>
+              <a:t>pumpovať</a:t>
+            </a:r>
+            <a:r>
+              <a:rPr lang="en-US" dirty="0"/>
+              <a:t> </a:t>
+            </a:r>
+            <a:r>
+              <a:rPr lang="en-US" dirty="0" err="1"/>
+              <a:t>krv</a:t>
+            </a:r>
+            <a:r>
+              <a:rPr lang="en-US" dirty="0"/>
+              <a:t> do </a:t>
+            </a:r>
+            <a:r>
+              <a:rPr lang="en-US" dirty="0" err="1"/>
+              <a:t>tela</a:t>
+            </a:r>
+            <a:r>
+              <a:rPr lang="en-US" dirty="0"/>
+              <a:t> </a:t>
+            </a:r>
+            <a:r>
+              <a:rPr lang="en-US" dirty="0" err="1"/>
+              <a:t>spôsobené</a:t>
+            </a:r>
+            <a:r>
+              <a:rPr lang="en-US" dirty="0"/>
+              <a:t> </a:t>
+            </a:r>
+            <a:r>
+              <a:rPr lang="en-US" dirty="0" err="1"/>
+              <a:t>rôznymi</a:t>
+            </a:r>
+            <a:r>
+              <a:rPr lang="en-US" dirty="0"/>
+              <a:t> </a:t>
+            </a:r>
+            <a:r>
+              <a:rPr lang="en-US" dirty="0" err="1"/>
+              <a:t>chorobami</a:t>
+            </a:r>
+            <a:r>
+              <a:rPr lang="en-US" dirty="0"/>
+              <a:t>.</a:t>
+            </a:r>
+          </a:p>
+          <a:p>
+            <a:endParaRPr lang="en-US" dirty="0">
+              <a:solidFill>
+                <a:schemeClr val="bg1"/>
+              </a:solidFill>
+            </a:endParaRPr>
+          </a:p>
+          <a:p>
+            <a:r>
+              <a:rPr lang="en-US" dirty="0" err="1">
+                <a:solidFill>
+                  <a:schemeClr val="bg1"/>
+                </a:solidFill>
+              </a:rPr>
+              <a:t>Môže</a:t>
+            </a:r>
+            <a:r>
+              <a:rPr lang="en-US" dirty="0">
+                <a:solidFill>
+                  <a:schemeClr val="bg1"/>
+                </a:solidFill>
+              </a:rPr>
+              <a:t> </a:t>
+            </a:r>
+            <a:r>
+              <a:rPr lang="en-US" dirty="0" err="1">
+                <a:solidFill>
+                  <a:schemeClr val="bg1"/>
+                </a:solidFill>
+              </a:rPr>
+              <a:t>byť</a:t>
+            </a:r>
+            <a:r>
+              <a:rPr lang="en-US" dirty="0">
+                <a:solidFill>
+                  <a:schemeClr val="bg1"/>
+                </a:solidFill>
+              </a:rPr>
+              <a:t>:</a:t>
+            </a:r>
+          </a:p>
+          <a:p>
+            <a:pPr marL="285750" indent="-285750">
+              <a:buFont typeface="Arial" panose="020B0604020202020204" pitchFamily="34" charset="0"/>
+              <a:buChar char="•"/>
+            </a:pPr>
+            <a:r>
+              <a:rPr lang="en-US" sz="1800" b="1" dirty="0" err="1">
+                <a:solidFill>
+                  <a:schemeClr val="bg1"/>
+                </a:solidFill>
+              </a:rPr>
+              <a:t>Akútne</a:t>
+            </a:r>
+            <a:r>
+              <a:rPr lang="en-US" dirty="0">
+                <a:solidFill>
+                  <a:schemeClr val="bg1"/>
+                </a:solidFill>
+              </a:rPr>
+              <a:t> (</a:t>
+            </a:r>
+            <a:r>
+              <a:rPr lang="en-US" dirty="0" err="1">
+                <a:solidFill>
+                  <a:schemeClr val="bg1"/>
+                </a:solidFill>
+              </a:rPr>
+              <a:t>napr</a:t>
+            </a:r>
+            <a:r>
+              <a:rPr lang="en-US" dirty="0">
+                <a:solidFill>
+                  <a:schemeClr val="bg1"/>
+                </a:solidFill>
+              </a:rPr>
+              <a:t>. </a:t>
+            </a:r>
+            <a:r>
+              <a:rPr lang="en-US" dirty="0" err="1"/>
+              <a:t>infarkt</a:t>
+            </a:r>
+            <a:r>
+              <a:rPr lang="en-US" dirty="0">
+                <a:solidFill>
+                  <a:schemeClr val="bg1"/>
+                </a:solidFill>
+              </a:rPr>
+              <a:t>)</a:t>
+            </a:r>
+          </a:p>
+          <a:p>
+            <a:pPr marL="285750" indent="-285750">
+              <a:buFont typeface="Arial" panose="020B0604020202020204" pitchFamily="34" charset="0"/>
+              <a:buChar char="•"/>
+            </a:pPr>
+            <a:r>
+              <a:rPr lang="en-US" sz="1800" b="1" dirty="0" err="1">
+                <a:solidFill>
+                  <a:schemeClr val="bg1"/>
+                </a:solidFill>
+              </a:rPr>
+              <a:t>Chronické</a:t>
+            </a:r>
+            <a:r>
+              <a:rPr lang="en-US" dirty="0">
+                <a:solidFill>
+                  <a:schemeClr val="bg1"/>
+                </a:solidFill>
+              </a:rPr>
+              <a:t> (</a:t>
+            </a:r>
+            <a:r>
+              <a:rPr lang="en-US" dirty="0" err="1">
+                <a:solidFill>
+                  <a:schemeClr val="bg1"/>
+                </a:solidFill>
+              </a:rPr>
+              <a:t>napr</a:t>
+            </a:r>
+            <a:r>
+              <a:rPr lang="en-US" dirty="0">
+                <a:solidFill>
+                  <a:schemeClr val="bg1"/>
+                </a:solidFill>
+              </a:rPr>
+              <a:t>. </a:t>
+            </a:r>
+            <a:r>
+              <a:rPr lang="en-US" dirty="0" err="1"/>
+              <a:t>hypertenzia</a:t>
+            </a:r>
+            <a:r>
+              <a:rPr lang="en-US" dirty="0"/>
+              <a:t>, </a:t>
+            </a:r>
+            <a:r>
+              <a:rPr lang="en-US" dirty="0" err="1"/>
+              <a:t>ateroskleróza</a:t>
+            </a:r>
+            <a:r>
+              <a:rPr lang="en-US" dirty="0">
+                <a:solidFill>
+                  <a:schemeClr val="bg1"/>
+                </a:solidFill>
+              </a:rPr>
+              <a:t>)</a:t>
+            </a:r>
+            <a:endParaRPr lang="en-US" dirty="0"/>
+          </a:p>
+        </p:txBody>
+      </p:sp>
+      <p:pic>
+        <p:nvPicPr>
+          <p:cNvPr id="7" name="Picture 6">
+            <a:extLst>
+              <a:ext uri="{FF2B5EF4-FFF2-40B4-BE49-F238E27FC236}">
+                <a16:creationId xmlns:a16="http://schemas.microsoft.com/office/drawing/2014/main" id="{01B399DE-799B-FA18-4160-8FD4B3886DDE}"/>
+              </a:ext>
+            </a:extLst>
+          </p:cNvPr>
+          <p:cNvPicPr>
+            <a:picLocks noChangeAspect="1"/>
+          </p:cNvPicPr>
+          <p:nvPr/>
+        </p:nvPicPr>
+        <p:blipFill>
+          <a:blip r:embed="rId2"/>
+          <a:stretch>
+            <a:fillRect/>
+          </a:stretch>
+        </p:blipFill>
+        <p:spPr>
+          <a:xfrm>
+            <a:off x="6653358" y="654717"/>
+            <a:ext cx="3514092" cy="5548566"/>
+          </a:xfrm>
+          <a:prstGeom prst="rect">
+            <a:avLst/>
+          </a:prstGeom>
+        </p:spPr>
+      </p:pic>
+    </p:spTree>
+    <p:extLst>
+      <p:ext uri="{BB962C8B-B14F-4D97-AF65-F5344CB8AC3E}">
+        <p14:creationId xmlns:p14="http://schemas.microsoft.com/office/powerpoint/2010/main" val="451721228"/>
+      </p:ext>
+    </p:extLst>
+  </p:cSld>
+  <p:clrMapOvr>
+    <a:masterClrMapping/>
+  </p:clrMapOvr>
+</p:sld>
+</file>
+
+<file path=ppt/slides/slide4.xml><?xml version="1.0" encoding="utf-8"?>
 <p:sld xmlns:a="http://schemas.openxmlformats.org/drawingml/2006/main" xmlns:r="http://schemas.openxmlformats.org/officeDocument/2006/relationships" xmlns:p="http://schemas.openxmlformats.org/presentationml/2006/main">
   <p:cSld>
     <p:spTree>
@@ -2657,7 +4219,7 @@
           <a:lstStyle/>
           <a:p>
             <a:r>
-              <a:rPr lang="sk-SK" dirty="0"/>
+              <a:rPr lang="sk-SK" b="0" dirty="0"/>
               <a:t>DÁTA A DATASETY</a:t>
             </a:r>
           </a:p>
@@ -2773,7 +4335,7 @@
 </p:sld>
 </file>
 
-<file path=ppt/slides/slide4.xml><?xml version="1.0" encoding="utf-8"?>
+<file path=ppt/slides/slide5.xml><?xml version="1.0" encoding="utf-8"?>
 <p:sld xmlns:a="http://schemas.openxmlformats.org/drawingml/2006/main" xmlns:r="http://schemas.openxmlformats.org/officeDocument/2006/relationships" xmlns:p="http://schemas.openxmlformats.org/presentationml/2006/main">
   <p:cSld>
     <p:spTree>
@@ -3650,7 +5212,7 @@
 </p:sld>
 </file>
 
-<file path=ppt/slides/slide5.xml><?xml version="1.0" encoding="utf-8"?>
+<file path=ppt/slides/slide6.xml><?xml version="1.0" encoding="utf-8"?>
 <p:sld xmlns:a="http://schemas.openxmlformats.org/drawingml/2006/main" xmlns:r="http://schemas.openxmlformats.org/officeDocument/2006/relationships" xmlns:p="http://schemas.openxmlformats.org/presentationml/2006/main">
   <p:cSld>
     <p:spTree>
@@ -3871,7 +5433,7 @@
 </p:sld>
 </file>
 
-<file path=ppt/slides/slide6.xml><?xml version="1.0" encoding="utf-8"?>
+<file path=ppt/slides/slide7.xml><?xml version="1.0" encoding="utf-8"?>
 <p:sld xmlns:a="http://schemas.openxmlformats.org/drawingml/2006/main" xmlns:r="http://schemas.openxmlformats.org/officeDocument/2006/relationships" xmlns:p="http://schemas.openxmlformats.org/presentationml/2006/main">
   <p:cSld>
     <p:spTree>
@@ -3934,7 +5496,7 @@
             <p:ph idx="1"/>
             <p:extLst>
               <p:ext uri="{D42A27DB-BD31-4B8C-83A1-F6EECF244321}">
-                <p14:modId xmlns:p14="http://schemas.microsoft.com/office/powerpoint/2010/main" val="3793226351"/>
+                <p14:modId xmlns:p14="http://schemas.microsoft.com/office/powerpoint/2010/main" val="1711205734"/>
               </p:ext>
             </p:extLst>
           </p:nvPr>
@@ -4483,14 +6045,14 @@
                         <a:buNone/>
                       </a:pPr>
                       <a:r>
-                        <a:rPr lang="en-US" sz="1100" b="0" u="none" strike="noStrike" dirty="0">
+                        <a:rPr lang="en-US" sz="1100" b="0" i="1" u="none" strike="noStrike" dirty="0">
                           <a:effectLst/>
                           <a:latin typeface="Clother" pitchFamily="2" charset="-79"/>
                           <a:cs typeface="Clother" pitchFamily="2" charset="-79"/>
                         </a:rPr>
                         <a:t>75</a:t>
                       </a:r>
-                      <a:endParaRPr lang="en-US" sz="1100" b="0" i="0" u="none" strike="noStrike" dirty="0">
+                      <a:endParaRPr lang="en-US" sz="1100" b="0" i="1" u="none" strike="noStrike" dirty="0">
                         <a:solidFill>
                           <a:srgbClr val="000000"/>
                         </a:solidFill>
@@ -4515,14 +6077,14 @@
                         <a:buNone/>
                       </a:pPr>
                       <a:r>
-                        <a:rPr lang="en-US" sz="1100" b="0" u="none" strike="noStrike" dirty="0">
+                        <a:rPr lang="en-US" sz="1100" b="0" i="1" u="none" strike="noStrike" dirty="0">
                           <a:effectLst/>
                           <a:latin typeface="Clother" pitchFamily="2" charset="-79"/>
                           <a:cs typeface="Clother" pitchFamily="2" charset="-79"/>
                         </a:rPr>
                         <a:t>0</a:t>
                       </a:r>
-                      <a:endParaRPr lang="en-US" sz="1100" b="0" i="0" u="none" strike="noStrike" dirty="0">
+                      <a:endParaRPr lang="en-US" sz="1100" b="0" i="1" u="none" strike="noStrike" dirty="0">
                         <a:solidFill>
                           <a:srgbClr val="000000"/>
                         </a:solidFill>
@@ -4547,14 +6109,14 @@
                         <a:buNone/>
                       </a:pPr>
                       <a:r>
-                        <a:rPr lang="en-US" sz="1100" b="0" u="none" strike="noStrike" dirty="0">
+                        <a:rPr lang="en-US" sz="1100" b="0" i="1" u="none" strike="noStrike" dirty="0">
                           <a:effectLst/>
                           <a:latin typeface="Clother" pitchFamily="2" charset="-79"/>
                           <a:cs typeface="Clother" pitchFamily="2" charset="-79"/>
                         </a:rPr>
                         <a:t>582</a:t>
                       </a:r>
-                      <a:endParaRPr lang="en-US" sz="1100" b="0" i="0" u="none" strike="noStrike" dirty="0">
+                      <a:endParaRPr lang="en-US" sz="1100" b="0" i="1" u="none" strike="noStrike" dirty="0">
                         <a:solidFill>
                           <a:srgbClr val="000000"/>
                         </a:solidFill>
@@ -4579,14 +6141,14 @@
                         <a:buNone/>
                       </a:pPr>
                       <a:r>
-                        <a:rPr lang="en-US" sz="1100" b="0" u="none" strike="noStrike" dirty="0">
+                        <a:rPr lang="en-US" sz="1100" b="0" i="1" u="none" strike="noStrike" dirty="0">
                           <a:effectLst/>
                           <a:latin typeface="Clother" pitchFamily="2" charset="-79"/>
                           <a:cs typeface="Clother" pitchFamily="2" charset="-79"/>
                         </a:rPr>
                         <a:t>0</a:t>
                       </a:r>
-                      <a:endParaRPr lang="en-US" sz="1100" b="0" i="0" u="none" strike="noStrike" dirty="0">
+                      <a:endParaRPr lang="en-US" sz="1100" b="0" i="1" u="none" strike="noStrike" dirty="0">
                         <a:solidFill>
                           <a:srgbClr val="000000"/>
                         </a:solidFill>
@@ -4611,14 +6173,14 @@
                         <a:buNone/>
                       </a:pPr>
                       <a:r>
-                        <a:rPr lang="en-US" sz="1100" b="0" u="none" strike="noStrike" dirty="0">
+                        <a:rPr lang="en-US" sz="1100" b="0" i="1" u="none" strike="noStrike" dirty="0">
                           <a:effectLst/>
                           <a:latin typeface="Clother" pitchFamily="2" charset="-79"/>
                           <a:cs typeface="Clother" pitchFamily="2" charset="-79"/>
                         </a:rPr>
                         <a:t>20</a:t>
                       </a:r>
-                      <a:endParaRPr lang="en-US" sz="1100" b="0" i="0" u="none" strike="noStrike" dirty="0">
+                      <a:endParaRPr lang="en-US" sz="1100" b="0" i="1" u="none" strike="noStrike" dirty="0">
                         <a:solidFill>
                           <a:srgbClr val="000000"/>
                         </a:solidFill>
@@ -4643,14 +6205,14 @@
                         <a:buNone/>
                       </a:pPr>
                       <a:r>
-                        <a:rPr lang="en-US" sz="1100" b="0" u="none" strike="noStrike" dirty="0">
+                        <a:rPr lang="en-US" sz="1100" b="0" i="1" u="none" strike="noStrike" dirty="0">
                           <a:effectLst/>
                           <a:latin typeface="Clother" pitchFamily="2" charset="-79"/>
                           <a:cs typeface="Clother" pitchFamily="2" charset="-79"/>
                         </a:rPr>
                         <a:t>1</a:t>
                       </a:r>
-                      <a:endParaRPr lang="en-US" sz="1100" b="0" i="0" u="none" strike="noStrike" dirty="0">
+                      <a:endParaRPr lang="en-US" sz="1100" b="0" i="1" u="none" strike="noStrike" dirty="0">
                         <a:solidFill>
                           <a:srgbClr val="000000"/>
                         </a:solidFill>
@@ -4675,14 +6237,14 @@
                         <a:buNone/>
                       </a:pPr>
                       <a:r>
-                        <a:rPr lang="en-US" sz="1100" b="0" u="none" strike="noStrike" dirty="0">
+                        <a:rPr lang="en-US" sz="1100" b="0" i="1" u="none" strike="noStrike" dirty="0">
                           <a:effectLst/>
                           <a:latin typeface="Clother" pitchFamily="2" charset="-79"/>
                           <a:cs typeface="Clother" pitchFamily="2" charset="-79"/>
                         </a:rPr>
                         <a:t>265000</a:t>
                       </a:r>
-                      <a:endParaRPr lang="en-US" sz="1100" b="0" i="0" u="none" strike="noStrike" dirty="0">
+                      <a:endParaRPr lang="en-US" sz="1100" b="0" i="1" u="none" strike="noStrike" dirty="0">
                         <a:solidFill>
                           <a:srgbClr val="000000"/>
                         </a:solidFill>
@@ -4707,14 +6269,14 @@
                         <a:buNone/>
                       </a:pPr>
                       <a:r>
-                        <a:rPr lang="en-US" sz="1100" b="0" u="none" strike="noStrike" dirty="0">
+                        <a:rPr lang="en-US" sz="1100" b="0" i="1" u="none" strike="noStrike" dirty="0">
                           <a:effectLst/>
                           <a:latin typeface="Clother" pitchFamily="2" charset="-79"/>
                           <a:cs typeface="Clother" pitchFamily="2" charset="-79"/>
                         </a:rPr>
                         <a:t>1.9</a:t>
                       </a:r>
-                      <a:endParaRPr lang="en-US" sz="1100" b="0" i="0" u="none" strike="noStrike" dirty="0">
+                      <a:endParaRPr lang="en-US" sz="1100" b="0" i="1" u="none" strike="noStrike" dirty="0">
                         <a:solidFill>
                           <a:srgbClr val="000000"/>
                         </a:solidFill>
@@ -4739,14 +6301,14 @@
                         <a:buNone/>
                       </a:pPr>
                       <a:r>
-                        <a:rPr lang="en-US" sz="1100" b="0" u="none" strike="noStrike" dirty="0">
+                        <a:rPr lang="en-US" sz="1100" b="0" i="1" u="none" strike="noStrike" dirty="0">
                           <a:effectLst/>
                           <a:latin typeface="Clother" pitchFamily="2" charset="-79"/>
                           <a:cs typeface="Clother" pitchFamily="2" charset="-79"/>
                         </a:rPr>
                         <a:t>130</a:t>
                       </a:r>
-                      <a:endParaRPr lang="en-US" sz="1100" b="0" i="0" u="none" strike="noStrike" dirty="0">
+                      <a:endParaRPr lang="en-US" sz="1100" b="0" i="1" u="none" strike="noStrike" dirty="0">
                         <a:solidFill>
                           <a:srgbClr val="000000"/>
                         </a:solidFill>
@@ -4771,14 +6333,14 @@
                         <a:buNone/>
                       </a:pPr>
                       <a:r>
-                        <a:rPr lang="en-US" sz="1100" b="0" u="none" strike="noStrike" dirty="0">
+                        <a:rPr lang="en-US" sz="1100" b="0" i="1" u="none" strike="noStrike" dirty="0">
                           <a:effectLst/>
                           <a:latin typeface="Clother" pitchFamily="2" charset="-79"/>
                           <a:cs typeface="Clother" pitchFamily="2" charset="-79"/>
                         </a:rPr>
                         <a:t>1</a:t>
                       </a:r>
-                      <a:endParaRPr lang="en-US" sz="1100" b="0" i="0" u="none" strike="noStrike" dirty="0">
+                      <a:endParaRPr lang="en-US" sz="1100" b="0" i="1" u="none" strike="noStrike" dirty="0">
                         <a:solidFill>
                           <a:srgbClr val="000000"/>
                         </a:solidFill>
@@ -4803,14 +6365,14 @@
                         <a:buNone/>
                       </a:pPr>
                       <a:r>
-                        <a:rPr lang="en-US" sz="1100" b="0" u="none" strike="noStrike" dirty="0">
+                        <a:rPr lang="en-US" sz="1100" b="0" i="1" u="none" strike="noStrike" dirty="0">
                           <a:effectLst/>
                           <a:latin typeface="Clother" pitchFamily="2" charset="-79"/>
                           <a:cs typeface="Clother" pitchFamily="2" charset="-79"/>
                         </a:rPr>
                         <a:t>0</a:t>
                       </a:r>
-                      <a:endParaRPr lang="en-US" sz="1100" b="0" i="0" u="none" strike="noStrike" dirty="0">
+                      <a:endParaRPr lang="en-US" sz="1100" b="0" i="1" u="none" strike="noStrike" dirty="0">
                         <a:solidFill>
                           <a:srgbClr val="000000"/>
                         </a:solidFill>
@@ -4835,14 +6397,14 @@
                         <a:buNone/>
                       </a:pPr>
                       <a:r>
-                        <a:rPr lang="en-US" sz="1100" b="0" u="none" strike="noStrike" dirty="0">
+                        <a:rPr lang="en-US" sz="1100" b="0" i="1" u="none" strike="noStrike" dirty="0">
                           <a:effectLst/>
                           <a:latin typeface="Clother" pitchFamily="2" charset="-79"/>
                           <a:cs typeface="Clother" pitchFamily="2" charset="-79"/>
                         </a:rPr>
                         <a:t>4</a:t>
                       </a:r>
-                      <a:endParaRPr lang="en-US" sz="1100" b="0" i="0" u="none" strike="noStrike" dirty="0">
+                      <a:endParaRPr lang="en-US" sz="1100" b="0" i="1" u="none" strike="noStrike" dirty="0">
                         <a:solidFill>
                           <a:srgbClr val="000000"/>
                         </a:solidFill>
@@ -4874,14 +6436,14 @@
                         <a:buNone/>
                       </a:pPr>
                       <a:r>
-                        <a:rPr lang="en-US" sz="1100" b="0" u="none" strike="noStrike">
+                        <a:rPr lang="en-US" sz="1100" b="0" i="1" u="none" strike="noStrike">
                           <a:effectLst/>
                           <a:latin typeface="Clother" pitchFamily="2" charset="-79"/>
                           <a:cs typeface="Clother" pitchFamily="2" charset="-79"/>
                         </a:rPr>
                         <a:t>55</a:t>
                       </a:r>
-                      <a:endParaRPr lang="en-US" sz="1100" b="0" i="0" u="none" strike="noStrike">
+                      <a:endParaRPr lang="en-US" sz="1100" b="0" i="1" u="none" strike="noStrike">
                         <a:solidFill>
                           <a:srgbClr val="000000"/>
                         </a:solidFill>
@@ -4906,14 +6468,14 @@
                         <a:buNone/>
                       </a:pPr>
                       <a:r>
-                        <a:rPr lang="en-US" sz="1100" b="0" u="none" strike="noStrike" dirty="0">
+                        <a:rPr lang="en-US" sz="1100" b="0" i="1" u="none" strike="noStrike" dirty="0">
                           <a:effectLst/>
                           <a:latin typeface="Clother" pitchFamily="2" charset="-79"/>
                           <a:cs typeface="Clother" pitchFamily="2" charset="-79"/>
                         </a:rPr>
                         <a:t>0</a:t>
                       </a:r>
-                      <a:endParaRPr lang="en-US" sz="1100" b="0" i="0" u="none" strike="noStrike" dirty="0">
+                      <a:endParaRPr lang="en-US" sz="1100" b="0" i="1" u="none" strike="noStrike" dirty="0">
                         <a:solidFill>
                           <a:srgbClr val="000000"/>
                         </a:solidFill>
@@ -4938,14 +6500,14 @@
                         <a:buNone/>
                       </a:pPr>
                       <a:r>
-                        <a:rPr lang="en-US" sz="1100" b="0" u="none" strike="noStrike" dirty="0">
+                        <a:rPr lang="en-US" sz="1100" b="0" i="1" u="none" strike="noStrike" dirty="0">
                           <a:effectLst/>
                           <a:latin typeface="Clother" pitchFamily="2" charset="-79"/>
                           <a:cs typeface="Clother" pitchFamily="2" charset="-79"/>
                         </a:rPr>
                         <a:t>7861</a:t>
                       </a:r>
-                      <a:endParaRPr lang="en-US" sz="1100" b="0" i="0" u="none" strike="noStrike" dirty="0">
+                      <a:endParaRPr lang="en-US" sz="1100" b="0" i="1" u="none" strike="noStrike" dirty="0">
                         <a:solidFill>
                           <a:srgbClr val="000000"/>
                         </a:solidFill>
@@ -4970,14 +6532,14 @@
                         <a:buNone/>
                       </a:pPr>
                       <a:r>
-                        <a:rPr lang="en-US" sz="1100" b="0" u="none" strike="noStrike">
+                        <a:rPr lang="en-US" sz="1100" b="0" i="1" u="none" strike="noStrike" dirty="0">
                           <a:effectLst/>
                           <a:latin typeface="Clother" pitchFamily="2" charset="-79"/>
                           <a:cs typeface="Clother" pitchFamily="2" charset="-79"/>
                         </a:rPr>
                         <a:t>0</a:t>
                       </a:r>
-                      <a:endParaRPr lang="en-US" sz="1100" b="0" i="0" u="none" strike="noStrike">
+                      <a:endParaRPr lang="en-US" sz="1100" b="0" i="1" u="none" strike="noStrike" dirty="0">
                         <a:solidFill>
                           <a:srgbClr val="000000"/>
                         </a:solidFill>
@@ -5002,14 +6564,14 @@
                         <a:buNone/>
                       </a:pPr>
                       <a:r>
-                        <a:rPr lang="en-US" sz="1100" b="0" u="none" strike="noStrike">
+                        <a:rPr lang="en-US" sz="1100" b="0" i="1" u="none" strike="noStrike">
                           <a:effectLst/>
                           <a:latin typeface="Clother" pitchFamily="2" charset="-79"/>
                           <a:cs typeface="Clother" pitchFamily="2" charset="-79"/>
                         </a:rPr>
                         <a:t>38</a:t>
                       </a:r>
-                      <a:endParaRPr lang="en-US" sz="1100" b="0" i="0" u="none" strike="noStrike">
+                      <a:endParaRPr lang="en-US" sz="1100" b="0" i="1" u="none" strike="noStrike">
                         <a:solidFill>
                           <a:srgbClr val="000000"/>
                         </a:solidFill>
@@ -5034,14 +6596,14 @@
                         <a:buNone/>
                       </a:pPr>
                       <a:r>
-                        <a:rPr lang="en-US" sz="1100" b="0" u="none" strike="noStrike">
+                        <a:rPr lang="en-US" sz="1100" b="0" i="1" u="none" strike="noStrike">
                           <a:effectLst/>
                           <a:latin typeface="Clother" pitchFamily="2" charset="-79"/>
                           <a:cs typeface="Clother" pitchFamily="2" charset="-79"/>
                         </a:rPr>
                         <a:t>0</a:t>
                       </a:r>
-                      <a:endParaRPr lang="en-US" sz="1100" b="0" i="0" u="none" strike="noStrike">
+                      <a:endParaRPr lang="en-US" sz="1100" b="0" i="1" u="none" strike="noStrike">
                         <a:solidFill>
                           <a:srgbClr val="000000"/>
                         </a:solidFill>
@@ -5066,14 +6628,14 @@
                         <a:buNone/>
                       </a:pPr>
                       <a:r>
-                        <a:rPr lang="en-US" sz="1100" b="0" u="none" strike="noStrike">
+                        <a:rPr lang="en-US" sz="1100" b="0" i="1" u="none" strike="noStrike">
                           <a:effectLst/>
                           <a:latin typeface="Clother" pitchFamily="2" charset="-79"/>
                           <a:cs typeface="Clother" pitchFamily="2" charset="-79"/>
                         </a:rPr>
                         <a:t>263358.03</a:t>
                       </a:r>
-                      <a:endParaRPr lang="en-US" sz="1100" b="0" i="0" u="none" strike="noStrike">
+                      <a:endParaRPr lang="en-US" sz="1100" b="0" i="1" u="none" strike="noStrike">
                         <a:solidFill>
                           <a:srgbClr val="000000"/>
                         </a:solidFill>
@@ -5098,14 +6660,14 @@
                         <a:buNone/>
                       </a:pPr>
                       <a:r>
-                        <a:rPr lang="en-US" sz="1100" b="0" u="none" strike="noStrike">
+                        <a:rPr lang="en-US" sz="1100" b="0" i="1" u="none" strike="noStrike">
                           <a:effectLst/>
                           <a:latin typeface="Clother" pitchFamily="2" charset="-79"/>
                           <a:cs typeface="Clother" pitchFamily="2" charset="-79"/>
                         </a:rPr>
                         <a:t>1.1</a:t>
                       </a:r>
-                      <a:endParaRPr lang="en-US" sz="1100" b="0" i="0" u="none" strike="noStrike">
+                      <a:endParaRPr lang="en-US" sz="1100" b="0" i="1" u="none" strike="noStrike">
                         <a:solidFill>
                           <a:srgbClr val="000000"/>
                         </a:solidFill>
@@ -5130,14 +6692,14 @@
                         <a:buNone/>
                       </a:pPr>
                       <a:r>
-                        <a:rPr lang="en-US" sz="1100" b="0" u="none" strike="noStrike">
+                        <a:rPr lang="en-US" sz="1100" b="0" i="1" u="none" strike="noStrike">
                           <a:effectLst/>
                           <a:latin typeface="Clother" pitchFamily="2" charset="-79"/>
                           <a:cs typeface="Clother" pitchFamily="2" charset="-79"/>
                         </a:rPr>
                         <a:t>136</a:t>
                       </a:r>
-                      <a:endParaRPr lang="en-US" sz="1100" b="0" i="0" u="none" strike="noStrike">
+                      <a:endParaRPr lang="en-US" sz="1100" b="0" i="1" u="none" strike="noStrike">
                         <a:solidFill>
                           <a:srgbClr val="000000"/>
                         </a:solidFill>
@@ -5162,14 +6724,14 @@
                         <a:buNone/>
                       </a:pPr>
                       <a:r>
-                        <a:rPr lang="en-US" sz="1100" b="0" u="none" strike="noStrike">
+                        <a:rPr lang="en-US" sz="1100" b="0" i="1" u="none" strike="noStrike">
                           <a:effectLst/>
                           <a:latin typeface="Clother" pitchFamily="2" charset="-79"/>
                           <a:cs typeface="Clother" pitchFamily="2" charset="-79"/>
                         </a:rPr>
                         <a:t>1</a:t>
                       </a:r>
-                      <a:endParaRPr lang="en-US" sz="1100" b="0" i="0" u="none" strike="noStrike">
+                      <a:endParaRPr lang="en-US" sz="1100" b="0" i="1" u="none" strike="noStrike">
                         <a:solidFill>
                           <a:srgbClr val="000000"/>
                         </a:solidFill>
@@ -5194,14 +6756,14 @@
                         <a:buNone/>
                       </a:pPr>
                       <a:r>
-                        <a:rPr lang="en-US" sz="1100" b="0" u="none" strike="noStrike">
+                        <a:rPr lang="en-US" sz="1100" b="0" i="1" u="none" strike="noStrike">
                           <a:effectLst/>
                           <a:latin typeface="Clother" pitchFamily="2" charset="-79"/>
                           <a:cs typeface="Clother" pitchFamily="2" charset="-79"/>
                         </a:rPr>
                         <a:t>0</a:t>
                       </a:r>
-                      <a:endParaRPr lang="en-US" sz="1100" b="0" i="0" u="none" strike="noStrike">
+                      <a:endParaRPr lang="en-US" sz="1100" b="0" i="1" u="none" strike="noStrike">
                         <a:solidFill>
                           <a:srgbClr val="000000"/>
                         </a:solidFill>
@@ -5226,14 +6788,14 @@
                         <a:buNone/>
                       </a:pPr>
                       <a:r>
-                        <a:rPr lang="en-US" sz="1100" b="0" u="none" strike="noStrike" dirty="0">
+                        <a:rPr lang="en-US" sz="1100" b="0" i="1" u="none" strike="noStrike" dirty="0">
                           <a:effectLst/>
                           <a:latin typeface="Clother" pitchFamily="2" charset="-79"/>
                           <a:cs typeface="Clother" pitchFamily="2" charset="-79"/>
                         </a:rPr>
                         <a:t>6</a:t>
                       </a:r>
-                      <a:endParaRPr lang="en-US" sz="1100" b="0" i="0" u="none" strike="noStrike" dirty="0">
+                      <a:endParaRPr lang="en-US" sz="1100" b="0" i="1" u="none" strike="noStrike" dirty="0">
                         <a:solidFill>
                           <a:srgbClr val="000000"/>
                         </a:solidFill>
@@ -5265,14 +6827,14 @@
                         <a:buNone/>
                       </a:pPr>
                       <a:r>
-                        <a:rPr lang="en-US" sz="1100" b="0" u="none" strike="noStrike">
+                        <a:rPr lang="en-US" sz="1100" b="0" i="1" u="none" strike="noStrike">
                           <a:effectLst/>
                           <a:latin typeface="Clother" pitchFamily="2" charset="-79"/>
                           <a:cs typeface="Clother" pitchFamily="2" charset="-79"/>
                         </a:rPr>
                         <a:t>65</a:t>
                       </a:r>
-                      <a:endParaRPr lang="en-US" sz="1100" b="0" i="0" u="none" strike="noStrike">
+                      <a:endParaRPr lang="en-US" sz="1100" b="0" i="1" u="none" strike="noStrike">
                         <a:solidFill>
                           <a:srgbClr val="000000"/>
                         </a:solidFill>
@@ -5297,14 +6859,14 @@
                         <a:buNone/>
                       </a:pPr>
                       <a:r>
-                        <a:rPr lang="en-US" sz="1100" b="0" u="none" strike="noStrike">
+                        <a:rPr lang="en-US" sz="1100" b="0" i="1" u="none" strike="noStrike">
                           <a:effectLst/>
                           <a:latin typeface="Clother" pitchFamily="2" charset="-79"/>
                           <a:cs typeface="Clother" pitchFamily="2" charset="-79"/>
                         </a:rPr>
                         <a:t>0</a:t>
                       </a:r>
-                      <a:endParaRPr lang="en-US" sz="1100" b="0" i="0" u="none" strike="noStrike">
+                      <a:endParaRPr lang="en-US" sz="1100" b="0" i="1" u="none" strike="noStrike">
                         <a:solidFill>
                           <a:srgbClr val="000000"/>
                         </a:solidFill>
@@ -5329,14 +6891,14 @@
                         <a:buNone/>
                       </a:pPr>
                       <a:r>
-                        <a:rPr lang="en-US" sz="1100" b="0" u="none" strike="noStrike" dirty="0">
+                        <a:rPr lang="en-US" sz="1100" b="0" i="1" u="none" strike="noStrike" dirty="0">
                           <a:effectLst/>
                           <a:latin typeface="Clother" pitchFamily="2" charset="-79"/>
                           <a:cs typeface="Clother" pitchFamily="2" charset="-79"/>
                         </a:rPr>
                         <a:t>146</a:t>
                       </a:r>
-                      <a:endParaRPr lang="en-US" sz="1100" b="0" i="0" u="none" strike="noStrike" dirty="0">
+                      <a:endParaRPr lang="en-US" sz="1100" b="0" i="1" u="none" strike="noStrike" dirty="0">
                         <a:solidFill>
                           <a:srgbClr val="000000"/>
                         </a:solidFill>
@@ -5361,14 +6923,14 @@
                         <a:buNone/>
                       </a:pPr>
                       <a:r>
-                        <a:rPr lang="en-US" sz="1100" b="0" u="none" strike="noStrike" dirty="0">
+                        <a:rPr lang="en-US" sz="1100" b="0" i="1" u="none" strike="noStrike" dirty="0">
                           <a:effectLst/>
                           <a:latin typeface="Clother" pitchFamily="2" charset="-79"/>
                           <a:cs typeface="Clother" pitchFamily="2" charset="-79"/>
                         </a:rPr>
                         <a:t>0</a:t>
                       </a:r>
-                      <a:endParaRPr lang="en-US" sz="1100" b="0" i="0" u="none" strike="noStrike" dirty="0">
+                      <a:endParaRPr lang="en-US" sz="1100" b="0" i="1" u="none" strike="noStrike" dirty="0">
                         <a:solidFill>
                           <a:srgbClr val="000000"/>
                         </a:solidFill>
@@ -5393,14 +6955,14 @@
                         <a:buNone/>
                       </a:pPr>
                       <a:r>
-                        <a:rPr lang="en-US" sz="1100" b="0" u="none" strike="noStrike">
+                        <a:rPr lang="en-US" sz="1100" b="0" i="1" u="none" strike="noStrike" dirty="0">
                           <a:effectLst/>
                           <a:latin typeface="Clother" pitchFamily="2" charset="-79"/>
                           <a:cs typeface="Clother" pitchFamily="2" charset="-79"/>
                         </a:rPr>
                         <a:t>20</a:t>
                       </a:r>
-                      <a:endParaRPr lang="en-US" sz="1100" b="0" i="0" u="none" strike="noStrike">
+                      <a:endParaRPr lang="en-US" sz="1100" b="0" i="1" u="none" strike="noStrike" dirty="0">
                         <a:solidFill>
                           <a:srgbClr val="000000"/>
                         </a:solidFill>
@@ -5425,14 +6987,14 @@
                         <a:buNone/>
                       </a:pPr>
                       <a:r>
-                        <a:rPr lang="en-US" sz="1100" b="0" u="none" strike="noStrike">
+                        <a:rPr lang="en-US" sz="1100" b="0" i="1" u="none" strike="noStrike" dirty="0">
                           <a:effectLst/>
                           <a:latin typeface="Clother" pitchFamily="2" charset="-79"/>
                           <a:cs typeface="Clother" pitchFamily="2" charset="-79"/>
                         </a:rPr>
                         <a:t>0</a:t>
                       </a:r>
-                      <a:endParaRPr lang="en-US" sz="1100" b="0" i="0" u="none" strike="noStrike">
+                      <a:endParaRPr lang="en-US" sz="1100" b="0" i="1" u="none" strike="noStrike" dirty="0">
                         <a:solidFill>
                           <a:srgbClr val="000000"/>
                         </a:solidFill>
@@ -5457,14 +7019,14 @@
                         <a:buNone/>
                       </a:pPr>
                       <a:r>
-                        <a:rPr lang="en-US" sz="1100" b="0" u="none" strike="noStrike">
+                        <a:rPr lang="en-US" sz="1100" b="0" i="1" u="none" strike="noStrike" dirty="0">
                           <a:effectLst/>
                           <a:latin typeface="Clother" pitchFamily="2" charset="-79"/>
                           <a:cs typeface="Clother" pitchFamily="2" charset="-79"/>
                         </a:rPr>
                         <a:t>162000</a:t>
                       </a:r>
-                      <a:endParaRPr lang="en-US" sz="1100" b="0" i="0" u="none" strike="noStrike">
+                      <a:endParaRPr lang="en-US" sz="1100" b="0" i="1" u="none" strike="noStrike" dirty="0">
                         <a:solidFill>
                           <a:srgbClr val="000000"/>
                         </a:solidFill>
@@ -5489,14 +7051,14 @@
                         <a:buNone/>
                       </a:pPr>
                       <a:r>
-                        <a:rPr lang="en-US" sz="1100" b="0" u="none" strike="noStrike">
+                        <a:rPr lang="en-US" sz="1100" b="0" i="1" u="none" strike="noStrike">
                           <a:effectLst/>
                           <a:latin typeface="Clother" pitchFamily="2" charset="-79"/>
                           <a:cs typeface="Clother" pitchFamily="2" charset="-79"/>
                         </a:rPr>
                         <a:t>1.3</a:t>
                       </a:r>
-                      <a:endParaRPr lang="en-US" sz="1100" b="0" i="0" u="none" strike="noStrike">
+                      <a:endParaRPr lang="en-US" sz="1100" b="0" i="1" u="none" strike="noStrike">
                         <a:solidFill>
                           <a:srgbClr val="000000"/>
                         </a:solidFill>
@@ -5521,14 +7083,14 @@
                         <a:buNone/>
                       </a:pPr>
                       <a:r>
-                        <a:rPr lang="en-US" sz="1100" b="0" u="none" strike="noStrike">
+                        <a:rPr lang="en-US" sz="1100" b="0" i="1" u="none" strike="noStrike">
                           <a:effectLst/>
                           <a:latin typeface="Clother" pitchFamily="2" charset="-79"/>
                           <a:cs typeface="Clother" pitchFamily="2" charset="-79"/>
                         </a:rPr>
                         <a:t>129</a:t>
                       </a:r>
-                      <a:endParaRPr lang="en-US" sz="1100" b="0" i="0" u="none" strike="noStrike">
+                      <a:endParaRPr lang="en-US" sz="1100" b="0" i="1" u="none" strike="noStrike">
                         <a:solidFill>
                           <a:srgbClr val="000000"/>
                         </a:solidFill>
@@ -5553,14 +7115,14 @@
                         <a:buNone/>
                       </a:pPr>
                       <a:r>
-                        <a:rPr lang="en-US" sz="1100" b="0" u="none" strike="noStrike" dirty="0">
+                        <a:rPr lang="en-US" sz="1100" b="0" i="1" u="none" strike="noStrike" dirty="0">
                           <a:effectLst/>
                           <a:latin typeface="Clother" pitchFamily="2" charset="-79"/>
                           <a:cs typeface="Clother" pitchFamily="2" charset="-79"/>
                         </a:rPr>
                         <a:t>1</a:t>
                       </a:r>
-                      <a:endParaRPr lang="en-US" sz="1100" b="0" i="0" u="none" strike="noStrike" dirty="0">
+                      <a:endParaRPr lang="en-US" sz="1100" b="0" i="1" u="none" strike="noStrike" dirty="0">
                         <a:solidFill>
                           <a:srgbClr val="000000"/>
                         </a:solidFill>
@@ -5585,14 +7147,14 @@
                         <a:buNone/>
                       </a:pPr>
                       <a:r>
-                        <a:rPr lang="en-US" sz="1100" b="0" u="none" strike="noStrike">
+                        <a:rPr lang="en-US" sz="1100" b="0" i="1" u="none" strike="noStrike">
                           <a:effectLst/>
                           <a:latin typeface="Clother" pitchFamily="2" charset="-79"/>
                           <a:cs typeface="Clother" pitchFamily="2" charset="-79"/>
                         </a:rPr>
                         <a:t>1</a:t>
                       </a:r>
-                      <a:endParaRPr lang="en-US" sz="1100" b="0" i="0" u="none" strike="noStrike">
+                      <a:endParaRPr lang="en-US" sz="1100" b="0" i="1" u="none" strike="noStrike">
                         <a:solidFill>
                           <a:srgbClr val="000000"/>
                         </a:solidFill>
@@ -5617,14 +7179,14 @@
                         <a:buNone/>
                       </a:pPr>
                       <a:r>
-                        <a:rPr lang="en-US" sz="1100" b="0" u="none" strike="noStrike" dirty="0">
+                        <a:rPr lang="en-US" sz="1100" b="0" i="1" u="none" strike="noStrike" dirty="0">
                           <a:effectLst/>
                           <a:latin typeface="Clother" pitchFamily="2" charset="-79"/>
                           <a:cs typeface="Clother" pitchFamily="2" charset="-79"/>
                         </a:rPr>
                         <a:t>7</a:t>
                       </a:r>
-                      <a:endParaRPr lang="en-US" sz="1100" b="0" i="0" u="none" strike="noStrike" dirty="0">
+                      <a:endParaRPr lang="en-US" sz="1100" b="0" i="1" u="none" strike="noStrike" dirty="0">
                         <a:solidFill>
                           <a:srgbClr val="000000"/>
                         </a:solidFill>
@@ -5656,14 +7218,14 @@
                         <a:buNone/>
                       </a:pPr>
                       <a:r>
-                        <a:rPr lang="en-US" sz="1100" b="0" u="none" strike="noStrike">
+                        <a:rPr lang="en-US" sz="1100" b="0" i="1" u="none" strike="noStrike">
                           <a:effectLst/>
                           <a:latin typeface="Clother" pitchFamily="2" charset="-79"/>
                           <a:cs typeface="Clother" pitchFamily="2" charset="-79"/>
                         </a:rPr>
                         <a:t>50</a:t>
                       </a:r>
-                      <a:endParaRPr lang="en-US" sz="1100" b="0" i="0" u="none" strike="noStrike">
+                      <a:endParaRPr lang="en-US" sz="1100" b="0" i="1" u="none" strike="noStrike">
                         <a:solidFill>
                           <a:srgbClr val="000000"/>
                         </a:solidFill>
@@ -5688,14 +7250,14 @@
                         <a:buNone/>
                       </a:pPr>
                       <a:r>
-                        <a:rPr lang="en-US" sz="1100" b="0" u="none" strike="noStrike">
+                        <a:rPr lang="en-US" sz="1100" b="0" i="1" u="none" strike="noStrike">
                           <a:effectLst/>
                           <a:latin typeface="Clother" pitchFamily="2" charset="-79"/>
                           <a:cs typeface="Clother" pitchFamily="2" charset="-79"/>
                         </a:rPr>
                         <a:t>1</a:t>
                       </a:r>
-                      <a:endParaRPr lang="en-US" sz="1100" b="0" i="0" u="none" strike="noStrike">
+                      <a:endParaRPr lang="en-US" sz="1100" b="0" i="1" u="none" strike="noStrike">
                         <a:solidFill>
                           <a:srgbClr val="000000"/>
                         </a:solidFill>
@@ -5720,14 +7282,14 @@
                         <a:buNone/>
                       </a:pPr>
                       <a:r>
-                        <a:rPr lang="en-US" sz="1100" b="0" u="none" strike="noStrike" dirty="0">
+                        <a:rPr lang="en-US" sz="1100" b="0" i="1" u="none" strike="noStrike" dirty="0">
                           <a:effectLst/>
                           <a:latin typeface="Clother" pitchFamily="2" charset="-79"/>
                           <a:cs typeface="Clother" pitchFamily="2" charset="-79"/>
                         </a:rPr>
                         <a:t>111</a:t>
                       </a:r>
-                      <a:endParaRPr lang="en-US" sz="1100" b="0" i="0" u="none" strike="noStrike" dirty="0">
+                      <a:endParaRPr lang="en-US" sz="1100" b="0" i="1" u="none" strike="noStrike" dirty="0">
                         <a:solidFill>
                           <a:srgbClr val="000000"/>
                         </a:solidFill>
@@ -5752,14 +7314,14 @@
                         <a:buNone/>
                       </a:pPr>
                       <a:r>
-                        <a:rPr lang="en-US" sz="1100" b="0" u="none" strike="noStrike" dirty="0">
+                        <a:rPr lang="en-US" sz="1100" b="0" i="1" u="none" strike="noStrike" dirty="0">
                           <a:effectLst/>
                           <a:latin typeface="Clother" pitchFamily="2" charset="-79"/>
                           <a:cs typeface="Clother" pitchFamily="2" charset="-79"/>
                         </a:rPr>
                         <a:t>0</a:t>
                       </a:r>
-                      <a:endParaRPr lang="en-US" sz="1100" b="0" i="0" u="none" strike="noStrike" dirty="0">
+                      <a:endParaRPr lang="en-US" sz="1100" b="0" i="1" u="none" strike="noStrike" dirty="0">
                         <a:solidFill>
                           <a:srgbClr val="000000"/>
                         </a:solidFill>
@@ -5784,14 +7346,14 @@
                         <a:buNone/>
                       </a:pPr>
                       <a:r>
-                        <a:rPr lang="en-US" sz="1100" b="0" u="none" strike="noStrike" dirty="0">
+                        <a:rPr lang="en-US" sz="1100" b="0" i="1" u="none" strike="noStrike" dirty="0">
                           <a:effectLst/>
                           <a:latin typeface="Clother" pitchFamily="2" charset="-79"/>
                           <a:cs typeface="Clother" pitchFamily="2" charset="-79"/>
                         </a:rPr>
                         <a:t>20</a:t>
                       </a:r>
-                      <a:endParaRPr lang="en-US" sz="1100" b="0" i="0" u="none" strike="noStrike" dirty="0">
+                      <a:endParaRPr lang="en-US" sz="1100" b="0" i="1" u="none" strike="noStrike" dirty="0">
                         <a:solidFill>
                           <a:srgbClr val="000000"/>
                         </a:solidFill>
@@ -5816,14 +7378,14 @@
                         <a:buNone/>
                       </a:pPr>
                       <a:r>
-                        <a:rPr lang="en-US" sz="1100" b="0" u="none" strike="noStrike" dirty="0">
+                        <a:rPr lang="en-US" sz="1100" b="0" i="1" u="none" strike="noStrike" dirty="0">
                           <a:effectLst/>
                           <a:latin typeface="Clother" pitchFamily="2" charset="-79"/>
                           <a:cs typeface="Clother" pitchFamily="2" charset="-79"/>
                         </a:rPr>
                         <a:t>0</a:t>
                       </a:r>
-                      <a:endParaRPr lang="en-US" sz="1100" b="0" i="0" u="none" strike="noStrike" dirty="0">
+                      <a:endParaRPr lang="en-US" sz="1100" b="0" i="1" u="none" strike="noStrike" dirty="0">
                         <a:solidFill>
                           <a:srgbClr val="000000"/>
                         </a:solidFill>
@@ -5848,14 +7410,14 @@
                         <a:buNone/>
                       </a:pPr>
                       <a:r>
-                        <a:rPr lang="en-US" sz="1100" b="0" u="none" strike="noStrike" dirty="0">
+                        <a:rPr lang="en-US" sz="1100" b="0" i="1" u="none" strike="noStrike" dirty="0">
                           <a:effectLst/>
                           <a:latin typeface="Clother" pitchFamily="2" charset="-79"/>
                           <a:cs typeface="Clother" pitchFamily="2" charset="-79"/>
                         </a:rPr>
                         <a:t>210000</a:t>
                       </a:r>
-                      <a:endParaRPr lang="en-US" sz="1100" b="0" i="0" u="none" strike="noStrike" dirty="0">
+                      <a:endParaRPr lang="en-US" sz="1100" b="0" i="1" u="none" strike="noStrike" dirty="0">
                         <a:solidFill>
                           <a:srgbClr val="000000"/>
                         </a:solidFill>
@@ -5880,14 +7442,14 @@
                         <a:buNone/>
                       </a:pPr>
                       <a:r>
-                        <a:rPr lang="en-US" sz="1100" b="0" u="none" strike="noStrike" dirty="0">
+                        <a:rPr lang="en-US" sz="1100" b="0" i="1" u="none" strike="noStrike" dirty="0">
                           <a:effectLst/>
                           <a:latin typeface="Clother" pitchFamily="2" charset="-79"/>
                           <a:cs typeface="Clother" pitchFamily="2" charset="-79"/>
                         </a:rPr>
                         <a:t>1.9</a:t>
                       </a:r>
-                      <a:endParaRPr lang="en-US" sz="1100" b="0" i="0" u="none" strike="noStrike" dirty="0">
+                      <a:endParaRPr lang="en-US" sz="1100" b="0" i="1" u="none" strike="noStrike" dirty="0">
                         <a:solidFill>
                           <a:srgbClr val="000000"/>
                         </a:solidFill>
@@ -5912,14 +7474,14 @@
                         <a:buNone/>
                       </a:pPr>
                       <a:r>
-                        <a:rPr lang="en-US" sz="1100" b="0" u="none" strike="noStrike" dirty="0">
+                        <a:rPr lang="en-US" sz="1100" b="0" i="1" u="none" strike="noStrike" dirty="0">
                           <a:effectLst/>
                           <a:latin typeface="Clother" pitchFamily="2" charset="-79"/>
                           <a:cs typeface="Clother" pitchFamily="2" charset="-79"/>
                         </a:rPr>
                         <a:t>137</a:t>
                       </a:r>
-                      <a:endParaRPr lang="en-US" sz="1100" b="0" i="0" u="none" strike="noStrike" dirty="0">
+                      <a:endParaRPr lang="en-US" sz="1100" b="0" i="1" u="none" strike="noStrike" dirty="0">
                         <a:solidFill>
                           <a:srgbClr val="000000"/>
                         </a:solidFill>
@@ -5944,14 +7506,14 @@
                         <a:buNone/>
                       </a:pPr>
                       <a:r>
-                        <a:rPr lang="en-US" sz="1100" b="0" u="none" strike="noStrike" dirty="0">
+                        <a:rPr lang="en-US" sz="1100" b="0" i="1" u="none" strike="noStrike" dirty="0">
                           <a:effectLst/>
                           <a:latin typeface="Clother" pitchFamily="2" charset="-79"/>
                           <a:cs typeface="Clother" pitchFamily="2" charset="-79"/>
                         </a:rPr>
                         <a:t>1</a:t>
                       </a:r>
-                      <a:endParaRPr lang="en-US" sz="1100" b="0" i="0" u="none" strike="noStrike" dirty="0">
+                      <a:endParaRPr lang="en-US" sz="1100" b="0" i="1" u="none" strike="noStrike" dirty="0">
                         <a:solidFill>
                           <a:srgbClr val="000000"/>
                         </a:solidFill>
@@ -5976,14 +7538,14 @@
                         <a:buNone/>
                       </a:pPr>
                       <a:r>
-                        <a:rPr lang="en-US" sz="1100" b="0" u="none" strike="noStrike">
+                        <a:rPr lang="en-US" sz="1100" b="0" i="1" u="none" strike="noStrike" dirty="0">
                           <a:effectLst/>
                           <a:latin typeface="Clother" pitchFamily="2" charset="-79"/>
                           <a:cs typeface="Clother" pitchFamily="2" charset="-79"/>
                         </a:rPr>
                         <a:t>0</a:t>
                       </a:r>
-                      <a:endParaRPr lang="en-US" sz="1100" b="0" i="0" u="none" strike="noStrike">
+                      <a:endParaRPr lang="en-US" sz="1100" b="0" i="1" u="none" strike="noStrike" dirty="0">
                         <a:solidFill>
                           <a:srgbClr val="000000"/>
                         </a:solidFill>
@@ -6008,14 +7570,14 @@
                         <a:buNone/>
                       </a:pPr>
                       <a:r>
-                        <a:rPr lang="en-US" sz="1100" b="0" u="none" strike="noStrike" dirty="0">
+                        <a:rPr lang="en-US" sz="1100" b="0" i="1" u="none" strike="noStrike" dirty="0">
                           <a:effectLst/>
                           <a:latin typeface="Clother" pitchFamily="2" charset="-79"/>
                           <a:cs typeface="Clother" pitchFamily="2" charset="-79"/>
                         </a:rPr>
                         <a:t>7</a:t>
                       </a:r>
-                      <a:endParaRPr lang="en-US" sz="1100" b="0" i="0" u="none" strike="noStrike" dirty="0">
+                      <a:endParaRPr lang="en-US" sz="1100" b="0" i="1" u="none" strike="noStrike" dirty="0">
                         <a:solidFill>
                           <a:srgbClr val="000000"/>
                         </a:solidFill>
@@ -6047,14 +7609,14 @@
                         <a:buNone/>
                       </a:pPr>
                       <a:r>
-                        <a:rPr lang="en-US" sz="1100" b="0" u="none" strike="noStrike">
+                        <a:rPr lang="en-US" sz="1100" b="0" i="1" u="none" strike="noStrike">
                           <a:effectLst/>
                           <a:latin typeface="Clother" pitchFamily="2" charset="-79"/>
                           <a:cs typeface="Clother" pitchFamily="2" charset="-79"/>
                         </a:rPr>
                         <a:t>65</a:t>
                       </a:r>
-                      <a:endParaRPr lang="en-US" sz="1100" b="0" i="0" u="none" strike="noStrike">
+                      <a:endParaRPr lang="en-US" sz="1100" b="0" i="1" u="none" strike="noStrike">
                         <a:solidFill>
                           <a:srgbClr val="000000"/>
                         </a:solidFill>
@@ -6079,14 +7641,14 @@
                         <a:buNone/>
                       </a:pPr>
                       <a:r>
-                        <a:rPr lang="en-US" sz="1100" b="0" u="none" strike="noStrike">
+                        <a:rPr lang="en-US" sz="1100" b="0" i="1" u="none" strike="noStrike">
                           <a:effectLst/>
                           <a:latin typeface="Clother" pitchFamily="2" charset="-79"/>
                           <a:cs typeface="Clother" pitchFamily="2" charset="-79"/>
                         </a:rPr>
                         <a:t>1</a:t>
                       </a:r>
-                      <a:endParaRPr lang="en-US" sz="1100" b="0" i="0" u="none" strike="noStrike">
+                      <a:endParaRPr lang="en-US" sz="1100" b="0" i="1" u="none" strike="noStrike">
                         <a:solidFill>
                           <a:srgbClr val="000000"/>
                         </a:solidFill>
@@ -6111,14 +7673,14 @@
                         <a:buNone/>
                       </a:pPr>
                       <a:r>
-                        <a:rPr lang="en-US" sz="1100" b="0" u="none" strike="noStrike">
+                        <a:rPr lang="en-US" sz="1100" b="0" i="1" u="none" strike="noStrike">
                           <a:effectLst/>
                           <a:latin typeface="Clother" pitchFamily="2" charset="-79"/>
                           <a:cs typeface="Clother" pitchFamily="2" charset="-79"/>
                         </a:rPr>
                         <a:t>160</a:t>
                       </a:r>
-                      <a:endParaRPr lang="en-US" sz="1100" b="0" i="0" u="none" strike="noStrike">
+                      <a:endParaRPr lang="en-US" sz="1100" b="0" i="1" u="none" strike="noStrike">
                         <a:solidFill>
                           <a:srgbClr val="000000"/>
                         </a:solidFill>
@@ -6143,14 +7705,14 @@
                         <a:buNone/>
                       </a:pPr>
                       <a:r>
-                        <a:rPr lang="en-US" sz="1100" b="0" u="none" strike="noStrike">
+                        <a:rPr lang="en-US" sz="1100" b="0" i="1" u="none" strike="noStrike">
                           <a:effectLst/>
                           <a:latin typeface="Clother" pitchFamily="2" charset="-79"/>
                           <a:cs typeface="Clother" pitchFamily="2" charset="-79"/>
                         </a:rPr>
                         <a:t>1</a:t>
                       </a:r>
-                      <a:endParaRPr lang="en-US" sz="1100" b="0" i="0" u="none" strike="noStrike">
+                      <a:endParaRPr lang="en-US" sz="1100" b="0" i="1" u="none" strike="noStrike">
                         <a:solidFill>
                           <a:srgbClr val="000000"/>
                         </a:solidFill>
@@ -6175,14 +7737,14 @@
                         <a:buNone/>
                       </a:pPr>
                       <a:r>
-                        <a:rPr lang="en-US" sz="1100" b="0" u="none" strike="noStrike" dirty="0">
+                        <a:rPr lang="en-US" sz="1100" b="0" i="1" u="none" strike="noStrike" dirty="0">
                           <a:effectLst/>
                           <a:latin typeface="Clother" pitchFamily="2" charset="-79"/>
                           <a:cs typeface="Clother" pitchFamily="2" charset="-79"/>
                         </a:rPr>
                         <a:t>20</a:t>
                       </a:r>
-                      <a:endParaRPr lang="en-US" sz="1100" b="0" i="0" u="none" strike="noStrike" dirty="0">
+                      <a:endParaRPr lang="en-US" sz="1100" b="0" i="1" u="none" strike="noStrike" dirty="0">
                         <a:solidFill>
                           <a:srgbClr val="000000"/>
                         </a:solidFill>
@@ -6207,14 +7769,14 @@
                         <a:buNone/>
                       </a:pPr>
                       <a:r>
-                        <a:rPr lang="en-US" sz="1100" b="0" u="none" strike="noStrike" dirty="0">
+                        <a:rPr lang="en-US" sz="1100" b="0" i="1" u="none" strike="noStrike" dirty="0">
                           <a:effectLst/>
                           <a:latin typeface="Clother" pitchFamily="2" charset="-79"/>
                           <a:cs typeface="Clother" pitchFamily="2" charset="-79"/>
                         </a:rPr>
                         <a:t>0</a:t>
                       </a:r>
-                      <a:endParaRPr lang="en-US" sz="1100" b="0" i="0" u="none" strike="noStrike" dirty="0">
+                      <a:endParaRPr lang="en-US" sz="1100" b="0" i="1" u="none" strike="noStrike" dirty="0">
                         <a:solidFill>
                           <a:srgbClr val="000000"/>
                         </a:solidFill>
@@ -6239,14 +7801,14 @@
                         <a:buNone/>
                       </a:pPr>
                       <a:r>
-                        <a:rPr lang="en-US" sz="1100" b="0" u="none" strike="noStrike" dirty="0">
+                        <a:rPr lang="en-US" sz="1100" b="0" i="1" u="none" strike="noStrike" dirty="0">
                           <a:effectLst/>
                           <a:latin typeface="Clother" pitchFamily="2" charset="-79"/>
                           <a:cs typeface="Clother" pitchFamily="2" charset="-79"/>
                         </a:rPr>
                         <a:t>327000</a:t>
                       </a:r>
-                      <a:endParaRPr lang="en-US" sz="1100" b="0" i="0" u="none" strike="noStrike" dirty="0">
+                      <a:endParaRPr lang="en-US" sz="1100" b="0" i="1" u="none" strike="noStrike" dirty="0">
                         <a:solidFill>
                           <a:srgbClr val="000000"/>
                         </a:solidFill>
@@ -6271,14 +7833,14 @@
                         <a:buNone/>
                       </a:pPr>
                       <a:r>
-                        <a:rPr lang="en-US" sz="1100" b="0" u="none" strike="noStrike" dirty="0">
+                        <a:rPr lang="en-US" sz="1100" b="0" i="1" u="none" strike="noStrike" dirty="0">
                           <a:effectLst/>
                           <a:latin typeface="Clother" pitchFamily="2" charset="-79"/>
                           <a:cs typeface="Clother" pitchFamily="2" charset="-79"/>
                         </a:rPr>
                         <a:t>2.7</a:t>
                       </a:r>
-                      <a:endParaRPr lang="en-US" sz="1100" b="0" i="0" u="none" strike="noStrike" dirty="0">
+                      <a:endParaRPr lang="en-US" sz="1100" b="0" i="1" u="none" strike="noStrike" dirty="0">
                         <a:solidFill>
                           <a:srgbClr val="000000"/>
                         </a:solidFill>
@@ -6303,14 +7865,14 @@
                         <a:buNone/>
                       </a:pPr>
                       <a:r>
-                        <a:rPr lang="en-US" sz="1100" b="0" u="none" strike="noStrike" dirty="0">
+                        <a:rPr lang="en-US" sz="1100" b="0" i="1" u="none" strike="noStrike" dirty="0">
                           <a:effectLst/>
                           <a:latin typeface="Clother" pitchFamily="2" charset="-79"/>
                           <a:cs typeface="Clother" pitchFamily="2" charset="-79"/>
                         </a:rPr>
                         <a:t>116</a:t>
                       </a:r>
-                      <a:endParaRPr lang="en-US" sz="1100" b="0" i="0" u="none" strike="noStrike" dirty="0">
+                      <a:endParaRPr lang="en-US" sz="1100" b="0" i="1" u="none" strike="noStrike" dirty="0">
                         <a:solidFill>
                           <a:srgbClr val="000000"/>
                         </a:solidFill>
@@ -6335,14 +7897,14 @@
                         <a:buNone/>
                       </a:pPr>
                       <a:r>
-                        <a:rPr lang="en-US" sz="1100" b="0" u="none" strike="noStrike" dirty="0">
+                        <a:rPr lang="en-US" sz="1100" b="0" i="1" u="none" strike="noStrike" dirty="0">
                           <a:effectLst/>
                           <a:latin typeface="Clother" pitchFamily="2" charset="-79"/>
                           <a:cs typeface="Clother" pitchFamily="2" charset="-79"/>
                         </a:rPr>
                         <a:t>0</a:t>
                       </a:r>
-                      <a:endParaRPr lang="en-US" sz="1100" b="0" i="0" u="none" strike="noStrike" dirty="0">
+                      <a:endParaRPr lang="en-US" sz="1100" b="0" i="1" u="none" strike="noStrike" dirty="0">
                         <a:solidFill>
                           <a:srgbClr val="000000"/>
                         </a:solidFill>
@@ -6367,14 +7929,14 @@
                         <a:buNone/>
                       </a:pPr>
                       <a:r>
-                        <a:rPr lang="en-US" sz="1100" b="0" u="none" strike="noStrike" dirty="0">
+                        <a:rPr lang="en-US" sz="1100" b="0" i="1" u="none" strike="noStrike" dirty="0">
                           <a:effectLst/>
                           <a:latin typeface="Clother" pitchFamily="2" charset="-79"/>
                           <a:cs typeface="Clother" pitchFamily="2" charset="-79"/>
                         </a:rPr>
                         <a:t>0</a:t>
                       </a:r>
-                      <a:endParaRPr lang="en-US" sz="1100" b="0" i="0" u="none" strike="noStrike" dirty="0">
+                      <a:endParaRPr lang="en-US" sz="1100" b="0" i="1" u="none" strike="noStrike" dirty="0">
                         <a:solidFill>
                           <a:srgbClr val="000000"/>
                         </a:solidFill>
@@ -6399,14 +7961,14 @@
                         <a:buNone/>
                       </a:pPr>
                       <a:r>
-                        <a:rPr lang="en-US" sz="1100" b="0" u="none" strike="noStrike" dirty="0">
+                        <a:rPr lang="en-US" sz="1100" b="0" i="1" u="none" strike="noStrike" dirty="0">
                           <a:effectLst/>
                           <a:latin typeface="Clother" pitchFamily="2" charset="-79"/>
                           <a:cs typeface="Clother" pitchFamily="2" charset="-79"/>
                         </a:rPr>
                         <a:t>8</a:t>
                       </a:r>
-                      <a:endParaRPr lang="en-US" sz="1100" b="0" i="0" u="none" strike="noStrike" dirty="0">
+                      <a:endParaRPr lang="en-US" sz="1100" b="0" i="1" u="none" strike="noStrike" dirty="0">
                         <a:solidFill>
                           <a:srgbClr val="000000"/>
                         </a:solidFill>
@@ -6445,7 +8007,7 @@
 </p:sld>
 </file>
 
-<file path=ppt/slides/slide7.xml><?xml version="1.0" encoding="utf-8"?>
+<file path=ppt/slides/slide8.xml><?xml version="1.0" encoding="utf-8"?>
 <p:sld xmlns:a="http://schemas.openxmlformats.org/drawingml/2006/main" xmlns:r="http://schemas.openxmlformats.org/officeDocument/2006/relationships" xmlns:p="http://schemas.openxmlformats.org/presentationml/2006/main">
   <p:cSld>
     <p:spTree>
@@ -6478,7 +8040,12 @@
             <p:ph type="title"/>
           </p:nvPr>
         </p:nvSpPr>
-        <p:spPr/>
+        <p:spPr>
+          <a:xfrm>
+            <a:off x="1478251" y="2170544"/>
+            <a:ext cx="3932237" cy="570345"/>
+          </a:xfrm>
+        </p:spPr>
         <p:txBody>
           <a:bodyPr/>
           <a:lstStyle/>
@@ -6487,31 +8054,6 @@
               <a:rPr lang="en-US" dirty="0"/>
               <a:t>STROJOVÉ UČENIE</a:t>
             </a:r>
-          </a:p>
-        </p:txBody>
-      </p:sp>
-      <p:sp>
-        <p:nvSpPr>
-          <p:cNvPr id="3" name="Picture Placeholder 2">
-            <a:extLst>
-              <a:ext uri="{FF2B5EF4-FFF2-40B4-BE49-F238E27FC236}">
-                <a16:creationId xmlns:a16="http://schemas.microsoft.com/office/drawing/2014/main" id="{05397853-E228-459F-4448-679977206AD0}"/>
-              </a:ext>
-            </a:extLst>
-          </p:cNvPr>
-          <p:cNvSpPr>
-            <a:spLocks noGrp="1"/>
-          </p:cNvSpPr>
-          <p:nvPr>
-            <p:ph type="pic" idx="1"/>
-          </p:nvPr>
-        </p:nvSpPr>
-        <p:spPr/>
-        <p:txBody>
-          <a:bodyPr/>
-          <a:lstStyle/>
-          <a:p>
-            <a:endParaRPr lang="en-US"/>
           </a:p>
         </p:txBody>
       </p:sp>
@@ -6531,70 +8073,707 @@
             <p:ph type="body" sz="half" idx="2"/>
           </p:nvPr>
         </p:nvSpPr>
-        <p:spPr/>
+        <p:spPr>
+          <a:xfrm>
+            <a:off x="1478251" y="2740890"/>
+            <a:ext cx="3932237" cy="2348346"/>
+          </a:xfrm>
+        </p:spPr>
         <p:txBody>
           <a:bodyPr/>
           <a:lstStyle/>
+          <a:p>
+            <a:r>
+              <a:rPr lang="en-US" dirty="0" err="1"/>
+              <a:t>Algoritmy</a:t>
+            </a:r>
+            <a:r>
+              <a:rPr lang="en-US" dirty="0">
+                <a:solidFill>
+                  <a:schemeClr val="bg1"/>
+                </a:solidFill>
+              </a:rPr>
+              <a:t>, </a:t>
+            </a:r>
+            <a:r>
+              <a:rPr lang="en-US" dirty="0" err="1">
+                <a:solidFill>
+                  <a:schemeClr val="bg1"/>
+                </a:solidFill>
+              </a:rPr>
+              <a:t>ktoré</a:t>
+            </a:r>
+            <a:r>
+              <a:rPr lang="en-US" dirty="0">
+                <a:solidFill>
+                  <a:schemeClr val="bg1"/>
+                </a:solidFill>
+              </a:rPr>
+              <a:t> </a:t>
+            </a:r>
+            <a:r>
+              <a:rPr lang="en-US" dirty="0" err="1">
+                <a:solidFill>
+                  <a:schemeClr val="bg1"/>
+                </a:solidFill>
+              </a:rPr>
+              <a:t>môžu</a:t>
+            </a:r>
+            <a:r>
+              <a:rPr lang="en-US" dirty="0">
+                <a:solidFill>
+                  <a:schemeClr val="bg1"/>
+                </a:solidFill>
+              </a:rPr>
+              <a:t> </a:t>
+            </a:r>
+            <a:r>
+              <a:rPr lang="en-US" dirty="0" err="1"/>
+              <a:t>predpovedať</a:t>
+            </a:r>
+            <a:r>
+              <a:rPr lang="en-US" dirty="0">
+                <a:solidFill>
+                  <a:schemeClr val="bg1"/>
+                </a:solidFill>
+              </a:rPr>
+              <a:t> </a:t>
+            </a:r>
+            <a:r>
+              <a:rPr lang="en-US" dirty="0" err="1">
+                <a:solidFill>
+                  <a:schemeClr val="bg1"/>
+                </a:solidFill>
+              </a:rPr>
+              <a:t>budúce</a:t>
+            </a:r>
+            <a:r>
+              <a:rPr lang="en-US" dirty="0">
+                <a:solidFill>
+                  <a:schemeClr val="bg1"/>
+                </a:solidFill>
+              </a:rPr>
+              <a:t> </a:t>
+            </a:r>
+            <a:r>
+              <a:rPr lang="en-US" dirty="0" err="1">
+                <a:solidFill>
+                  <a:schemeClr val="bg1"/>
+                </a:solidFill>
+              </a:rPr>
+              <a:t>deje</a:t>
+            </a:r>
+            <a:r>
+              <a:rPr lang="en-US" dirty="0">
+                <a:solidFill>
+                  <a:schemeClr val="bg1"/>
+                </a:solidFill>
+              </a:rPr>
+              <a:t> </a:t>
+            </a:r>
+            <a:r>
+              <a:rPr lang="en-US" dirty="0" err="1">
+                <a:solidFill>
+                  <a:schemeClr val="bg1"/>
+                </a:solidFill>
+              </a:rPr>
+              <a:t>na</a:t>
+            </a:r>
+            <a:r>
+              <a:rPr lang="en-US" dirty="0">
+                <a:solidFill>
+                  <a:schemeClr val="bg1"/>
+                </a:solidFill>
+              </a:rPr>
+              <a:t> </a:t>
+            </a:r>
+            <a:r>
+              <a:rPr lang="en-US" dirty="0" err="1">
+                <a:solidFill>
+                  <a:schemeClr val="bg1"/>
+                </a:solidFill>
+              </a:rPr>
+              <a:t>základe</a:t>
+            </a:r>
+            <a:r>
+              <a:rPr lang="en-US" dirty="0">
+                <a:solidFill>
+                  <a:schemeClr val="bg1"/>
+                </a:solidFill>
+              </a:rPr>
+              <a:t> </a:t>
+            </a:r>
+            <a:r>
+              <a:rPr lang="en-US" dirty="0" err="1"/>
+              <a:t>historických</a:t>
+            </a:r>
+            <a:r>
+              <a:rPr lang="en-US" dirty="0"/>
+              <a:t> </a:t>
+            </a:r>
+            <a:r>
+              <a:rPr lang="en-US" dirty="0" err="1"/>
+              <a:t>dát</a:t>
+            </a:r>
+            <a:endParaRPr lang="en-US" dirty="0"/>
+          </a:p>
+          <a:p>
+            <a:endParaRPr lang="en-US" dirty="0"/>
+          </a:p>
+          <a:p>
+            <a:r>
+              <a:rPr lang="en-US" dirty="0" err="1"/>
+              <a:t>Postup</a:t>
+            </a:r>
+            <a:r>
+              <a:rPr lang="en-US" dirty="0"/>
+              <a:t> </a:t>
+            </a:r>
+            <a:r>
+              <a:rPr lang="en-US" dirty="0" err="1"/>
+              <a:t>Strojového</a:t>
+            </a:r>
+            <a:r>
+              <a:rPr lang="en-US" dirty="0"/>
+              <a:t> </a:t>
+            </a:r>
+            <a:r>
+              <a:rPr lang="en-US" dirty="0" err="1"/>
+              <a:t>učenia</a:t>
+            </a:r>
+            <a:endParaRPr lang="en-US" dirty="0"/>
+          </a:p>
           <a:p>
             <a:pPr marL="285750" indent="-285750">
               <a:buFont typeface="Arial" panose="020B0604020202020204" pitchFamily="34" charset="0"/>
               <a:buChar char="•"/>
             </a:pPr>
             <a:r>
-              <a:rPr lang="en-US" dirty="0" err="1"/>
-              <a:t>Proces</a:t>
-            </a:r>
-            <a:r>
-              <a:rPr lang="en-US" dirty="0"/>
+              <a:rPr lang="en-US" dirty="0" err="1">
+                <a:solidFill>
+                  <a:srgbClr val="865DFF"/>
+                </a:solidFill>
+              </a:rPr>
+              <a:t>Vložíme</a:t>
+            </a:r>
+            <a:r>
+              <a:rPr lang="en-US" dirty="0">
+                <a:solidFill>
+                  <a:schemeClr val="bg1"/>
+                </a:solidFill>
+              </a:rPr>
               <a:t> </a:t>
             </a:r>
             <a:r>
-              <a:rPr lang="en-US" dirty="0" err="1"/>
-              <a:t>učenia</a:t>
-            </a:r>
-            <a:r>
-              <a:rPr lang="en-US" dirty="0"/>
+              <a:rPr lang="en-US" dirty="0" err="1">
+                <a:solidFill>
+                  <a:schemeClr val="bg1"/>
+                </a:solidFill>
+              </a:rPr>
+              <a:t>upravené</a:t>
+            </a:r>
+            <a:r>
+              <a:rPr lang="en-US" dirty="0">
+                <a:solidFill>
+                  <a:schemeClr val="bg1"/>
+                </a:solidFill>
+              </a:rPr>
               <a:t> </a:t>
             </a:r>
             <a:r>
-              <a:rPr lang="en-US" dirty="0" err="1"/>
-              <a:t>nejakého</a:t>
-            </a:r>
-            <a:r>
-              <a:rPr lang="en-US" dirty="0"/>
+              <a:rPr lang="en-US" dirty="0" err="1">
+                <a:solidFill>
+                  <a:schemeClr val="bg1"/>
+                </a:solidFill>
+              </a:rPr>
+              <a:t>dáta</a:t>
+            </a:r>
+            <a:endParaRPr lang="en-US" dirty="0">
+              <a:solidFill>
+                <a:schemeClr val="bg1"/>
+              </a:solidFill>
+            </a:endParaRPr>
+          </a:p>
+          <a:p>
+            <a:pPr marL="285750" indent="-285750">
+              <a:buFont typeface="Arial" panose="020B0604020202020204" pitchFamily="34" charset="0"/>
+              <a:buChar char="•"/>
+            </a:pPr>
+            <a:r>
+              <a:rPr lang="en-US" dirty="0" err="1">
+                <a:solidFill>
+                  <a:srgbClr val="865DFF"/>
+                </a:solidFill>
+              </a:rPr>
+              <a:t>Natrénujeme</a:t>
+            </a:r>
+            <a:r>
+              <a:rPr lang="en-US" dirty="0">
+                <a:solidFill>
+                  <a:schemeClr val="bg1"/>
+                </a:solidFill>
+              </a:rPr>
+              <a:t> model</a:t>
+            </a:r>
+          </a:p>
+          <a:p>
+            <a:pPr marL="285750" indent="-285750">
+              <a:buFont typeface="Arial" panose="020B0604020202020204" pitchFamily="34" charset="0"/>
+              <a:buChar char="•"/>
+            </a:pPr>
+            <a:r>
+              <a:rPr lang="en-US" dirty="0" err="1">
+                <a:solidFill>
+                  <a:srgbClr val="865DFF"/>
+                </a:solidFill>
+              </a:rPr>
+              <a:t>Vyhodnotíme</a:t>
+            </a:r>
+            <a:r>
+              <a:rPr lang="en-US" dirty="0">
+                <a:solidFill>
+                  <a:schemeClr val="bg1"/>
+                </a:solidFill>
+              </a:rPr>
               <a:t> </a:t>
             </a:r>
             <a:r>
-              <a:rPr lang="en-US" dirty="0" err="1"/>
-              <a:t>modelu</a:t>
-            </a:r>
-            <a:r>
-              <a:rPr lang="en-US" dirty="0"/>
-              <a:t>  z </a:t>
-            </a:r>
-            <a:r>
-              <a:rPr lang="en-US" dirty="0" err="1"/>
-              <a:t>historických</a:t>
-            </a:r>
-            <a:r>
-              <a:rPr lang="en-US" dirty="0"/>
+              <a:rPr lang="en-US" dirty="0" err="1">
+                <a:solidFill>
+                  <a:schemeClr val="bg1"/>
+                </a:solidFill>
+              </a:rPr>
+              <a:t>jeho</a:t>
+            </a:r>
+            <a:r>
+              <a:rPr lang="en-US" dirty="0">
+                <a:solidFill>
+                  <a:schemeClr val="bg1"/>
+                </a:solidFill>
+              </a:rPr>
               <a:t> </a:t>
             </a:r>
             <a:r>
-              <a:rPr lang="en-US" dirty="0" err="1"/>
-              <a:t>dát</a:t>
-            </a:r>
-            <a:r>
-              <a:rPr lang="en-US" dirty="0"/>
-              <a:t>.</a:t>
-            </a:r>
+              <a:rPr lang="en-US" dirty="0" err="1">
+                <a:solidFill>
+                  <a:schemeClr val="bg1"/>
+                </a:solidFill>
+              </a:rPr>
+              <a:t>výkon</a:t>
+            </a:r>
+            <a:endParaRPr lang="en-US" dirty="0">
+              <a:solidFill>
+                <a:schemeClr val="bg1"/>
+              </a:solidFill>
+            </a:endParaRPr>
           </a:p>
         </p:txBody>
       </p:sp>
+      <p:pic>
+        <p:nvPicPr>
+          <p:cNvPr id="9" name="Picture 8">
+            <a:extLst>
+              <a:ext uri="{FF2B5EF4-FFF2-40B4-BE49-F238E27FC236}">
+                <a16:creationId xmlns:a16="http://schemas.microsoft.com/office/drawing/2014/main" id="{C562957E-0E1E-A18F-6A7D-AC509571127A}"/>
+              </a:ext>
+            </a:extLst>
+          </p:cNvPr>
+          <p:cNvPicPr>
+            <a:picLocks noChangeAspect="1"/>
+          </p:cNvPicPr>
+          <p:nvPr/>
+        </p:nvPicPr>
+        <p:blipFill>
+          <a:blip r:embed="rId2"/>
+          <a:stretch>
+            <a:fillRect/>
+          </a:stretch>
+        </p:blipFill>
+        <p:spPr>
+          <a:xfrm>
+            <a:off x="6096000" y="1248280"/>
+            <a:ext cx="4968730" cy="4361440"/>
+          </a:xfrm>
+          <a:prstGeom prst="rect">
+            <a:avLst/>
+          </a:prstGeom>
+        </p:spPr>
+      </p:pic>
     </p:spTree>
     <p:extLst>
       <p:ext uri="{BB962C8B-B14F-4D97-AF65-F5344CB8AC3E}">
         <p14:creationId xmlns:p14="http://schemas.microsoft.com/office/powerpoint/2010/main" val="732499979"/>
+      </p:ext>
+    </p:extLst>
+  </p:cSld>
+  <p:clrMapOvr>
+    <a:masterClrMapping/>
+  </p:clrMapOvr>
+</p:sld>
+</file>
+
+<file path=ppt/slides/slide9.xml><?xml version="1.0" encoding="utf-8"?>
+<p:sld xmlns:a="http://schemas.openxmlformats.org/drawingml/2006/main" xmlns:r="http://schemas.openxmlformats.org/officeDocument/2006/relationships" xmlns:p="http://schemas.openxmlformats.org/presentationml/2006/main">
+  <p:cSld>
+    <p:spTree>
+      <p:nvGrpSpPr>
+        <p:cNvPr id="1" name=""/>
+        <p:cNvGrpSpPr/>
+        <p:nvPr/>
+      </p:nvGrpSpPr>
+      <p:grpSpPr>
+        <a:xfrm>
+          <a:off x="0" y="0"/>
+          <a:ext cx="0" cy="0"/>
+          <a:chOff x="0" y="0"/>
+          <a:chExt cx="0" cy="0"/>
+        </a:xfrm>
+      </p:grpSpPr>
+      <p:sp>
+        <p:nvSpPr>
+          <p:cNvPr id="2" name="Title 1">
+            <a:extLst>
+              <a:ext uri="{FF2B5EF4-FFF2-40B4-BE49-F238E27FC236}">
+                <a16:creationId xmlns:a16="http://schemas.microsoft.com/office/drawing/2014/main" id="{443084DE-19EC-0455-AF0D-611AA641F020}"/>
+              </a:ext>
+            </a:extLst>
+          </p:cNvPr>
+          <p:cNvSpPr>
+            <a:spLocks noGrp="1"/>
+          </p:cNvSpPr>
+          <p:nvPr>
+            <p:ph type="title"/>
+          </p:nvPr>
+        </p:nvSpPr>
+        <p:spPr>
+          <a:xfrm>
+            <a:off x="1331190" y="1284835"/>
+            <a:ext cx="3932237" cy="1600200"/>
+          </a:xfrm>
+        </p:spPr>
+        <p:txBody>
+          <a:bodyPr/>
+          <a:lstStyle/>
+          <a:p>
+            <a:r>
+              <a:rPr lang="en-US" dirty="0"/>
+              <a:t>POUŽITÝ MODEL</a:t>
+            </a:r>
+          </a:p>
+        </p:txBody>
+      </p:sp>
+      <p:sp>
+        <p:nvSpPr>
+          <p:cNvPr id="4" name="Text Placeholder 3">
+            <a:extLst>
+              <a:ext uri="{FF2B5EF4-FFF2-40B4-BE49-F238E27FC236}">
+                <a16:creationId xmlns:a16="http://schemas.microsoft.com/office/drawing/2014/main" id="{89FABF58-9408-7726-80C2-46892A627E3E}"/>
+              </a:ext>
+            </a:extLst>
+          </p:cNvPr>
+          <p:cNvSpPr>
+            <a:spLocks noGrp="1"/>
+          </p:cNvSpPr>
+          <p:nvPr>
+            <p:ph type="body" sz="half" idx="2"/>
+          </p:nvPr>
+        </p:nvSpPr>
+        <p:spPr>
+          <a:xfrm>
+            <a:off x="1331190" y="2885035"/>
+            <a:ext cx="3932237" cy="1600200"/>
+          </a:xfrm>
+        </p:spPr>
+        <p:txBody>
+          <a:bodyPr/>
+          <a:lstStyle/>
+          <a:p>
+            <a:r>
+              <a:rPr lang="en-US" dirty="0"/>
+              <a:t>Decision Tree (</a:t>
+            </a:r>
+            <a:r>
+              <a:rPr lang="en-US" dirty="0" err="1"/>
+              <a:t>Rozhodovací</a:t>
+            </a:r>
+            <a:r>
+              <a:rPr lang="en-US" dirty="0"/>
+              <a:t> </a:t>
+            </a:r>
+            <a:r>
+              <a:rPr lang="en-US" dirty="0" err="1"/>
+              <a:t>strom</a:t>
+            </a:r>
+            <a:r>
+              <a:rPr lang="en-US" dirty="0"/>
+              <a:t>)</a:t>
+            </a:r>
+          </a:p>
+          <a:p>
+            <a:endParaRPr lang="en-US" dirty="0"/>
+          </a:p>
+          <a:p>
+            <a:r>
+              <a:rPr lang="en-US" dirty="0" err="1">
+                <a:solidFill>
+                  <a:schemeClr val="bg1"/>
+                </a:solidFill>
+              </a:rPr>
+              <a:t>Tento</a:t>
+            </a:r>
+            <a:r>
+              <a:rPr lang="en-US" dirty="0">
+                <a:solidFill>
+                  <a:schemeClr val="bg1"/>
+                </a:solidFill>
+              </a:rPr>
+              <a:t> </a:t>
+            </a:r>
+            <a:r>
+              <a:rPr lang="en-US" dirty="0" err="1">
+                <a:solidFill>
+                  <a:schemeClr val="bg1"/>
+                </a:solidFill>
+              </a:rPr>
+              <a:t>algoritmus</a:t>
+            </a:r>
+            <a:r>
+              <a:rPr lang="en-US" dirty="0">
+                <a:solidFill>
+                  <a:schemeClr val="bg1"/>
+                </a:solidFill>
+              </a:rPr>
+              <a:t> </a:t>
+            </a:r>
+            <a:r>
+              <a:rPr lang="en-US" dirty="0" err="1">
+                <a:solidFill>
+                  <a:schemeClr val="bg1"/>
+                </a:solidFill>
+              </a:rPr>
+              <a:t>sa</a:t>
+            </a:r>
+            <a:r>
+              <a:rPr lang="en-US" dirty="0">
+                <a:solidFill>
+                  <a:schemeClr val="bg1"/>
+                </a:solidFill>
+              </a:rPr>
+              <a:t> </a:t>
+            </a:r>
+            <a:r>
+              <a:rPr lang="en-US" dirty="0" err="1"/>
+              <a:t>rozhoduje</a:t>
+            </a:r>
+            <a:r>
+              <a:rPr lang="en-US" dirty="0">
+                <a:solidFill>
+                  <a:schemeClr val="bg1"/>
+                </a:solidFill>
+              </a:rPr>
+              <a:t>, </a:t>
+            </a:r>
+            <a:r>
+              <a:rPr lang="en-US" dirty="0" err="1">
+                <a:solidFill>
+                  <a:schemeClr val="bg1"/>
+                </a:solidFill>
+              </a:rPr>
+              <a:t>ako</a:t>
+            </a:r>
+            <a:r>
+              <a:rPr lang="en-US" dirty="0">
+                <a:solidFill>
+                  <a:schemeClr val="bg1"/>
+                </a:solidFill>
+              </a:rPr>
+              <a:t> </a:t>
+            </a:r>
+            <a:r>
+              <a:rPr lang="en-US" dirty="0" err="1"/>
+              <a:t>rozdeliť</a:t>
+            </a:r>
+            <a:r>
+              <a:rPr lang="en-US" dirty="0"/>
+              <a:t> </a:t>
+            </a:r>
+            <a:r>
+              <a:rPr lang="en-US" dirty="0" err="1">
+                <a:solidFill>
+                  <a:schemeClr val="bg1"/>
+                </a:solidFill>
+              </a:rPr>
+              <a:t>dáta</a:t>
+            </a:r>
+            <a:r>
+              <a:rPr lang="en-US" dirty="0"/>
+              <a:t> </a:t>
+            </a:r>
+            <a:r>
+              <a:rPr lang="en-US" dirty="0">
+                <a:solidFill>
+                  <a:schemeClr val="bg1"/>
+                </a:solidFill>
+              </a:rPr>
+              <a:t>do</a:t>
+            </a:r>
+            <a:r>
+              <a:rPr lang="en-US" dirty="0"/>
+              <a:t> </a:t>
+            </a:r>
+            <a:r>
+              <a:rPr lang="en-US" dirty="0" err="1"/>
+              <a:t>skupín</a:t>
+            </a:r>
+            <a:r>
+              <a:rPr lang="en-US" dirty="0"/>
+              <a:t> </a:t>
+            </a:r>
+            <a:r>
+              <a:rPr lang="en-US" dirty="0" err="1">
+                <a:solidFill>
+                  <a:schemeClr val="bg1"/>
+                </a:solidFill>
+              </a:rPr>
+              <a:t>na</a:t>
+            </a:r>
+            <a:r>
+              <a:rPr lang="en-US" dirty="0">
+                <a:solidFill>
+                  <a:schemeClr val="bg1"/>
+                </a:solidFill>
+              </a:rPr>
+              <a:t> </a:t>
+            </a:r>
+            <a:r>
+              <a:rPr lang="en-US" dirty="0" err="1">
+                <a:solidFill>
+                  <a:schemeClr val="bg1"/>
+                </a:solidFill>
+              </a:rPr>
+              <a:t>základe</a:t>
+            </a:r>
+            <a:r>
+              <a:rPr lang="en-US" dirty="0">
+                <a:solidFill>
+                  <a:schemeClr val="bg1"/>
+                </a:solidFill>
+              </a:rPr>
+              <a:t> </a:t>
+            </a:r>
+            <a:r>
+              <a:rPr lang="en-US" dirty="0" err="1"/>
+              <a:t>atribútov</a:t>
+            </a:r>
+            <a:r>
+              <a:rPr lang="en-US" dirty="0">
+                <a:solidFill>
+                  <a:schemeClr val="bg1"/>
+                </a:solidFill>
+              </a:rPr>
+              <a:t> (</a:t>
+            </a:r>
+            <a:r>
+              <a:rPr lang="en-US" dirty="0" err="1">
+                <a:solidFill>
+                  <a:schemeClr val="bg1"/>
+                </a:solidFill>
+              </a:rPr>
+              <a:t>napr</a:t>
+            </a:r>
+            <a:r>
+              <a:rPr lang="en-US" dirty="0">
+                <a:solidFill>
+                  <a:schemeClr val="bg1"/>
+                </a:solidFill>
+              </a:rPr>
+              <a:t>. </a:t>
+            </a:r>
+            <a:r>
+              <a:rPr lang="en-US" dirty="0" err="1">
+                <a:solidFill>
+                  <a:schemeClr val="bg1"/>
+                </a:solidFill>
+              </a:rPr>
+              <a:t>podľa</a:t>
+            </a:r>
+            <a:r>
+              <a:rPr lang="en-US" dirty="0">
+                <a:solidFill>
+                  <a:schemeClr val="bg1"/>
+                </a:solidFill>
+              </a:rPr>
+              <a:t> </a:t>
+            </a:r>
+            <a:r>
+              <a:rPr lang="en-US" dirty="0" err="1">
+                <a:solidFill>
+                  <a:schemeClr val="bg1"/>
+                </a:solidFill>
+              </a:rPr>
+              <a:t>veku</a:t>
+            </a:r>
+            <a:r>
+              <a:rPr lang="en-US" dirty="0">
+                <a:solidFill>
+                  <a:schemeClr val="bg1"/>
+                </a:solidFill>
+              </a:rPr>
+              <a:t>, </a:t>
+            </a:r>
+            <a:r>
+              <a:rPr lang="en-US" dirty="0" err="1">
+                <a:solidFill>
+                  <a:schemeClr val="bg1"/>
+                </a:solidFill>
+              </a:rPr>
+              <a:t>známok</a:t>
+            </a:r>
+            <a:r>
+              <a:rPr lang="en-US" dirty="0">
+                <a:solidFill>
+                  <a:schemeClr val="bg1"/>
+                </a:solidFill>
+              </a:rPr>
+              <a:t>…)</a:t>
+            </a:r>
+          </a:p>
+        </p:txBody>
+      </p:sp>
+      <p:pic>
+        <p:nvPicPr>
+          <p:cNvPr id="6" name="Picture 5">
+            <a:extLst>
+              <a:ext uri="{FF2B5EF4-FFF2-40B4-BE49-F238E27FC236}">
+                <a16:creationId xmlns:a16="http://schemas.microsoft.com/office/drawing/2014/main" id="{5792B6D2-670E-17AA-3AE8-C11836E326AB}"/>
+              </a:ext>
+            </a:extLst>
+          </p:cNvPr>
+          <p:cNvPicPr>
+            <a:picLocks noChangeAspect="1"/>
+          </p:cNvPicPr>
+          <p:nvPr/>
+        </p:nvPicPr>
+        <p:blipFill>
+          <a:blip r:embed="rId2"/>
+          <a:stretch>
+            <a:fillRect/>
+          </a:stretch>
+        </p:blipFill>
+        <p:spPr>
+          <a:xfrm>
+            <a:off x="6096000" y="1284835"/>
+            <a:ext cx="4764810" cy="4288329"/>
+          </a:xfrm>
+          <a:prstGeom prst="rect">
+            <a:avLst/>
+          </a:prstGeom>
+        </p:spPr>
+      </p:pic>
+    </p:spTree>
+    <p:extLst>
+      <p:ext uri="{BB962C8B-B14F-4D97-AF65-F5344CB8AC3E}">
+        <p14:creationId xmlns:p14="http://schemas.microsoft.com/office/powerpoint/2010/main" val="3288261547"/>
       </p:ext>
     </p:extLst>
   </p:cSld>

</xml_diff>